<commit_message>
Brief deck: rendered Lucide icons + real accuracy mini-chart
20 professional line icons rendered locally (react-icons/lucide -> PNG)
replace the ASCII glyph badges: themed icon badges on slide 1's four
generation pillars + idea-card headers, and per-method icon chips across
all 12 Innovation Studio tiles. Slide 2's bottom band becomes two cards:
a drawn held-out accuracy mini-chart (mass vs feature MAPE, real
benchmark values at one decimal) and the proof/next-step card with
shield/play icons. All icons verified in-bounds; validation passed.

Co-Authored-By: Claude Fable 5 <noreply@anthropic.com>
Claude-Session: https://claude.ai/code/session_019qdUjZ8WZYLU54FEixJk1i
</commit_message>
<xml_diff>
--- a/BrainSpark_Director_Brief.pptx
+++ b/BrainSpark_Director_Brief.pptx
@@ -3959,7 +3959,7 @@
         <p:spPr>
           <a:xfrm>
             <a:off x="548640" y="1965960"/>
-            <a:ext cx="420624" cy="420624"/>
+            <a:ext cx="457200" cy="457200"/>
           </a:xfrm>
           <a:prstGeom prst="roundRect">
             <a:avLst/>
@@ -3994,45 +3994,30 @@
           </a:p>
         </p:txBody>
       </p:sp>
-      <p:sp>
-        <p:nvSpPr>
-          <p:cNvPr id="11" name="TextBox 10"/>
-          <p:cNvSpPr txBox="1"/>
-          <p:nvPr/>
-        </p:nvSpPr>
-        <p:spPr>
-          <a:xfrm>
-            <a:off x="548640" y="1965960"/>
-            <a:ext cx="420624" cy="420624"/>
-          </a:xfrm>
-          <a:prstGeom prst="rect">
-            <a:avLst/>
-          </a:prstGeom>
-          <a:noFill/>
-        </p:spPr>
-        <p:txBody>
-          <a:bodyPr wrap="square" anchor="ctr" lIns="0" rIns="0" tIns="0" bIns="0">
-            <a:spAutoFit/>
-          </a:bodyPr>
-          <a:lstStyle/>
-          <a:p>
-            <a:pPr algn="ctr">
-              <a:lnSpc>
-                <a:spcPct val="100000"/>
-              </a:lnSpc>
-            </a:pPr>
-            <a:r>
-              <a:rPr sz="1500" b="1">
-                <a:solidFill>
-                  <a:srgbClr val="FFFFFF"/>
-                </a:solidFill>
-                <a:latin typeface="Arial"/>
-              </a:rPr>
-              <a:t>◆</a:t>
-            </a:r>
-          </a:p>
-        </p:txBody>
-      </p:sp>
+      <p:pic>
+        <p:nvPicPr>
+          <p:cNvPr id="11" name="Picture 10" descr="globe.png"/>
+          <p:cNvPicPr>
+            <a:picLocks noChangeAspect="1"/>
+          </p:cNvPicPr>
+          <p:nvPr/>
+        </p:nvPicPr>
+        <p:blipFill>
+          <a:blip r:embed="rId2"/>
+          <a:stretch>
+            <a:fillRect/>
+          </a:stretch>
+        </p:blipFill>
+        <p:spPr>
+          <a:xfrm>
+            <a:off x="644652" y="2061972"/>
+            <a:ext cx="265176" cy="265176"/>
+          </a:xfrm>
+          <a:prstGeom prst="rect">
+            <a:avLst/>
+          </a:prstGeom>
+        </p:spPr>
+      </p:pic>
       <p:sp>
         <p:nvSpPr>
           <p:cNvPr id="12" name="TextBox 11"/>
@@ -4041,7 +4026,7 @@
         </p:nvSpPr>
         <p:spPr>
           <a:xfrm>
-            <a:off x="1143000" y="1929384"/>
+            <a:off x="1170432" y="1929384"/>
             <a:ext cx="5486400" cy="310896"/>
           </a:xfrm>
           <a:prstGeom prst="rect">
@@ -4080,8 +4065,8 @@
         </p:nvSpPr>
         <p:spPr>
           <a:xfrm>
-            <a:off x="1143000" y="2249424"/>
-            <a:ext cx="5532120" cy="777240"/>
+            <a:off x="1170432" y="2249424"/>
+            <a:ext cx="5504688" cy="777240"/>
           </a:xfrm>
           <a:prstGeom prst="rect">
             <a:avLst/>
@@ -4120,7 +4105,7 @@
         <p:spPr>
           <a:xfrm>
             <a:off x="548640" y="3035808"/>
-            <a:ext cx="420624" cy="420624"/>
+            <a:ext cx="457200" cy="457200"/>
           </a:xfrm>
           <a:prstGeom prst="roundRect">
             <a:avLst/>
@@ -4155,45 +4140,30 @@
           </a:p>
         </p:txBody>
       </p:sp>
-      <p:sp>
-        <p:nvSpPr>
-          <p:cNvPr id="15" name="TextBox 14"/>
-          <p:cNvSpPr txBox="1"/>
-          <p:nvPr/>
-        </p:nvSpPr>
-        <p:spPr>
-          <a:xfrm>
-            <a:off x="548640" y="3035808"/>
-            <a:ext cx="420624" cy="420624"/>
-          </a:xfrm>
-          <a:prstGeom prst="rect">
-            <a:avLst/>
-          </a:prstGeom>
-          <a:noFill/>
-        </p:spPr>
-        <p:txBody>
-          <a:bodyPr wrap="square" anchor="ctr" lIns="0" rIns="0" tIns="0" bIns="0">
-            <a:spAutoFit/>
-          </a:bodyPr>
-          <a:lstStyle/>
-          <a:p>
-            <a:pPr algn="ctr">
-              <a:lnSpc>
-                <a:spcPct val="100000"/>
-              </a:lnSpc>
-            </a:pPr>
-            <a:r>
-              <a:rPr sz="1500" b="1">
-                <a:solidFill>
-                  <a:srgbClr val="FFFFFF"/>
-                </a:solidFill>
-                <a:latin typeface="Arial"/>
-              </a:rPr>
-              <a:t>★</a:t>
-            </a:r>
-          </a:p>
-        </p:txBody>
-      </p:sp>
+      <p:pic>
+        <p:nvPicPr>
+          <p:cNvPr id="15" name="Picture 14" descr="brain.png"/>
+          <p:cNvPicPr>
+            <a:picLocks noChangeAspect="1"/>
+          </p:cNvPicPr>
+          <p:nvPr/>
+        </p:nvPicPr>
+        <p:blipFill>
+          <a:blip r:embed="rId3"/>
+          <a:stretch>
+            <a:fillRect/>
+          </a:stretch>
+        </p:blipFill>
+        <p:spPr>
+          <a:xfrm>
+            <a:off x="644652" y="3131820"/>
+            <a:ext cx="265176" cy="265176"/>
+          </a:xfrm>
+          <a:prstGeom prst="rect">
+            <a:avLst/>
+          </a:prstGeom>
+        </p:spPr>
+      </p:pic>
       <p:sp>
         <p:nvSpPr>
           <p:cNvPr id="16" name="TextBox 15"/>
@@ -4202,7 +4172,7 @@
         </p:nvSpPr>
         <p:spPr>
           <a:xfrm>
-            <a:off x="1143000" y="2999232"/>
+            <a:off x="1170432" y="2999232"/>
             <a:ext cx="5486400" cy="310896"/>
           </a:xfrm>
           <a:prstGeom prst="rect">
@@ -4241,8 +4211,8 @@
         </p:nvSpPr>
         <p:spPr>
           <a:xfrm>
-            <a:off x="1143000" y="3319272"/>
-            <a:ext cx="5532120" cy="777240"/>
+            <a:off x="1170432" y="3319272"/>
+            <a:ext cx="5504688" cy="777240"/>
           </a:xfrm>
           <a:prstGeom prst="rect">
             <a:avLst/>
@@ -4281,7 +4251,7 @@
         <p:spPr>
           <a:xfrm>
             <a:off x="548640" y="4105656"/>
-            <a:ext cx="420624" cy="420624"/>
+            <a:ext cx="457200" cy="457200"/>
           </a:xfrm>
           <a:prstGeom prst="roundRect">
             <a:avLst/>
@@ -4316,45 +4286,30 @@
           </a:p>
         </p:txBody>
       </p:sp>
-      <p:sp>
-        <p:nvSpPr>
-          <p:cNvPr id="19" name="TextBox 18"/>
-          <p:cNvSpPr txBox="1"/>
-          <p:nvPr/>
-        </p:nvSpPr>
-        <p:spPr>
-          <a:xfrm>
-            <a:off x="548640" y="4105656"/>
-            <a:ext cx="420624" cy="420624"/>
-          </a:xfrm>
-          <a:prstGeom prst="rect">
-            <a:avLst/>
-          </a:prstGeom>
-          <a:noFill/>
-        </p:spPr>
-        <p:txBody>
-          <a:bodyPr wrap="square" anchor="ctr" lIns="0" rIns="0" tIns="0" bIns="0">
-            <a:spAutoFit/>
-          </a:bodyPr>
-          <a:lstStyle/>
-          <a:p>
-            <a:pPr algn="ctr">
-              <a:lnSpc>
-                <a:spcPct val="100000"/>
-              </a:lnSpc>
-            </a:pPr>
-            <a:r>
-              <a:rPr sz="1500" b="1">
-                <a:solidFill>
-                  <a:srgbClr val="FFFFFF"/>
-                </a:solidFill>
-                <a:latin typeface="Arial"/>
-              </a:rPr>
-              <a:t>▲</a:t>
-            </a:r>
-          </a:p>
-        </p:txBody>
-      </p:sp>
+      <p:pic>
+        <p:nvPicPr>
+          <p:cNvPr id="19" name="Picture 18" descr="users.png"/>
+          <p:cNvPicPr>
+            <a:picLocks noChangeAspect="1"/>
+          </p:cNvPicPr>
+          <p:nvPr/>
+        </p:nvPicPr>
+        <p:blipFill>
+          <a:blip r:embed="rId4"/>
+          <a:stretch>
+            <a:fillRect/>
+          </a:stretch>
+        </p:blipFill>
+        <p:spPr>
+          <a:xfrm>
+            <a:off x="644652" y="4201668"/>
+            <a:ext cx="265176" cy="265176"/>
+          </a:xfrm>
+          <a:prstGeom prst="rect">
+            <a:avLst/>
+          </a:prstGeom>
+        </p:spPr>
+      </p:pic>
       <p:sp>
         <p:nvSpPr>
           <p:cNvPr id="20" name="TextBox 19"/>
@@ -4363,7 +4318,7 @@
         </p:nvSpPr>
         <p:spPr>
           <a:xfrm>
-            <a:off x="1143000" y="4069080"/>
+            <a:off x="1170432" y="4069080"/>
             <a:ext cx="5486400" cy="310896"/>
           </a:xfrm>
           <a:prstGeom prst="rect">
@@ -4402,8 +4357,8 @@
         </p:nvSpPr>
         <p:spPr>
           <a:xfrm>
-            <a:off x="1143000" y="4389120"/>
-            <a:ext cx="5532120" cy="777240"/>
+            <a:off x="1170432" y="4389120"/>
+            <a:ext cx="5504688" cy="777240"/>
           </a:xfrm>
           <a:prstGeom prst="rect">
             <a:avLst/>
@@ -4442,7 +4397,7 @@
         <p:spPr>
           <a:xfrm>
             <a:off x="548640" y="5175504"/>
-            <a:ext cx="420624" cy="420624"/>
+            <a:ext cx="457200" cy="457200"/>
           </a:xfrm>
           <a:prstGeom prst="roundRect">
             <a:avLst/>
@@ -4477,45 +4432,30 @@
           </a:p>
         </p:txBody>
       </p:sp>
-      <p:sp>
-        <p:nvSpPr>
-          <p:cNvPr id="23" name="TextBox 22"/>
-          <p:cNvSpPr txBox="1"/>
-          <p:nvPr/>
-        </p:nvSpPr>
-        <p:spPr>
-          <a:xfrm>
-            <a:off x="548640" y="5175504"/>
-            <a:ext cx="420624" cy="420624"/>
-          </a:xfrm>
-          <a:prstGeom prst="rect">
-            <a:avLst/>
-          </a:prstGeom>
-          <a:noFill/>
-        </p:spPr>
-        <p:txBody>
-          <a:bodyPr wrap="square" anchor="ctr" lIns="0" rIns="0" tIns="0" bIns="0">
-            <a:spAutoFit/>
-          </a:bodyPr>
-          <a:lstStyle/>
-          <a:p>
-            <a:pPr algn="ctr">
-              <a:lnSpc>
-                <a:spcPct val="100000"/>
-              </a:lnSpc>
-            </a:pPr>
-            <a:r>
-              <a:rPr sz="1500" b="1">
-                <a:solidFill>
-                  <a:srgbClr val="FFFFFF"/>
-                </a:solidFill>
-                <a:latin typeface="Arial"/>
-              </a:rPr>
-              <a:t>✓</a:t>
-            </a:r>
-          </a:p>
-        </p:txBody>
-      </p:sp>
+      <p:pic>
+        <p:nvPicPr>
+          <p:cNvPr id="23" name="Picture 22" descr="badge.png"/>
+          <p:cNvPicPr>
+            <a:picLocks noChangeAspect="1"/>
+          </p:cNvPicPr>
+          <p:nvPr/>
+        </p:nvPicPr>
+        <p:blipFill>
+          <a:blip r:embed="rId5"/>
+          <a:stretch>
+            <a:fillRect/>
+          </a:stretch>
+        </p:blipFill>
+        <p:spPr>
+          <a:xfrm>
+            <a:off x="644652" y="5271516"/>
+            <a:ext cx="265176" cy="265176"/>
+          </a:xfrm>
+          <a:prstGeom prst="rect">
+            <a:avLst/>
+          </a:prstGeom>
+        </p:spPr>
+      </p:pic>
       <p:sp>
         <p:nvSpPr>
           <p:cNvPr id="24" name="TextBox 23"/>
@@ -4524,7 +4464,7 @@
         </p:nvSpPr>
         <p:spPr>
           <a:xfrm>
-            <a:off x="1143000" y="5138928"/>
+            <a:off x="1170432" y="5138928"/>
             <a:ext cx="5486400" cy="310896"/>
           </a:xfrm>
           <a:prstGeom prst="rect">
@@ -4563,8 +4503,8 @@
         </p:nvSpPr>
         <p:spPr>
           <a:xfrm>
-            <a:off x="1143000" y="5458968"/>
-            <a:ext cx="5532120" cy="777240"/>
+            <a:off x="1170432" y="5458968"/>
+            <a:ext cx="5504688" cy="777240"/>
           </a:xfrm>
           <a:prstGeom prst="rect">
             <a:avLst/>
@@ -4642,14 +4582,82 @@
       </p:sp>
       <p:sp>
         <p:nvSpPr>
-          <p:cNvPr id="27" name="TextBox 26"/>
+          <p:cNvPr id="27" name="Rounded Rectangle 26"/>
+          <p:cNvSpPr/>
+          <p:nvPr/>
+        </p:nvSpPr>
+        <p:spPr>
+          <a:xfrm>
+            <a:off x="7223760" y="2048256"/>
+            <a:ext cx="292608" cy="292608"/>
+          </a:xfrm>
+          <a:prstGeom prst="roundRect">
+            <a:avLst/>
+          </a:prstGeom>
+          <a:solidFill>
+            <a:srgbClr val="B47609"/>
+          </a:solidFill>
+          <a:ln>
+            <a:noFill/>
+          </a:ln>
+          <a:effectLst/>
+        </p:spPr>
+        <p:style>
+          <a:lnRef idx="1">
+            <a:schemeClr val="accent1"/>
+          </a:lnRef>
+          <a:fillRef idx="3">
+            <a:schemeClr val="accent1"/>
+          </a:fillRef>
+          <a:effectRef idx="2">
+            <a:schemeClr val="accent1"/>
+          </a:effectRef>
+          <a:fontRef idx="minor">
+            <a:schemeClr val="lt1"/>
+          </a:fontRef>
+        </p:style>
+        <p:txBody>
+          <a:bodyPr rtlCol="0" anchor="ctr"/>
+          <a:lstStyle/>
+          <a:p>
+            <a:pPr algn="ctr"/>
+          </a:p>
+        </p:txBody>
+      </p:sp>
+      <p:pic>
+        <p:nvPicPr>
+          <p:cNvPr id="28" name="Picture 27" descr="bulb.png"/>
+          <p:cNvPicPr>
+            <a:picLocks noChangeAspect="1"/>
+          </p:cNvPicPr>
+          <p:nvPr/>
+        </p:nvPicPr>
+        <p:blipFill>
+          <a:blip r:embed="rId6"/>
+          <a:stretch>
+            <a:fillRect/>
+          </a:stretch>
+        </p:blipFill>
+        <p:spPr>
+          <a:xfrm>
+            <a:off x="7276429" y="2100925"/>
+            <a:ext cx="187270" cy="187270"/>
+          </a:xfrm>
+          <a:prstGeom prst="rect">
+            <a:avLst/>
+          </a:prstGeom>
+        </p:spPr>
+      </p:pic>
+      <p:sp>
+        <p:nvSpPr>
+          <p:cNvPr id="29" name="TextBox 28"/>
           <p:cNvSpPr txBox="1"/>
           <p:nvPr/>
         </p:nvSpPr>
         <p:spPr>
           <a:xfrm>
-            <a:off x="7223760" y="2084831"/>
-            <a:ext cx="4206240" cy="292608"/>
+            <a:off x="7607808" y="2084831"/>
+            <a:ext cx="3840480" cy="292608"/>
           </a:xfrm>
           <a:prstGeom prst="rect">
             <a:avLst/>
@@ -4681,7 +4689,7 @@
       </p:sp>
       <p:sp>
         <p:nvSpPr>
-          <p:cNvPr id="28" name="Rounded Rectangle 27"/>
+          <p:cNvPr id="30" name="Rounded Rectangle 29"/>
           <p:cNvSpPr/>
           <p:nvPr/>
         </p:nvSpPr>
@@ -4727,7 +4735,7 @@
       </p:sp>
       <p:sp>
         <p:nvSpPr>
-          <p:cNvPr id="29" name="TextBox 28"/>
+          <p:cNvPr id="31" name="TextBox 30"/>
           <p:cNvSpPr txBox="1"/>
           <p:nvPr/>
         </p:nvSpPr>
@@ -4766,7 +4774,7 @@
       </p:sp>
       <p:sp>
         <p:nvSpPr>
-          <p:cNvPr id="30" name="TextBox 29"/>
+          <p:cNvPr id="32" name="TextBox 31"/>
           <p:cNvSpPr txBox="1"/>
           <p:nvPr/>
         </p:nvSpPr>
@@ -4805,7 +4813,7 @@
       </p:sp>
       <p:sp>
         <p:nvSpPr>
-          <p:cNvPr id="31" name="Rounded Rectangle 30"/>
+          <p:cNvPr id="33" name="Rounded Rectangle 32"/>
           <p:cNvSpPr/>
           <p:nvPr/>
         </p:nvSpPr>
@@ -4849,7 +4857,7 @@
       </p:sp>
       <p:sp>
         <p:nvSpPr>
-          <p:cNvPr id="32" name="TextBox 31"/>
+          <p:cNvPr id="34" name="TextBox 33"/>
           <p:cNvSpPr txBox="1"/>
           <p:nvPr/>
         </p:nvSpPr>
@@ -4888,7 +4896,7 @@
       </p:sp>
       <p:sp>
         <p:nvSpPr>
-          <p:cNvPr id="33" name="Rounded Rectangle 32"/>
+          <p:cNvPr id="35" name="Rounded Rectangle 34"/>
           <p:cNvSpPr/>
           <p:nvPr/>
         </p:nvSpPr>
@@ -4932,7 +4940,7 @@
       </p:sp>
       <p:sp>
         <p:nvSpPr>
-          <p:cNvPr id="34" name="TextBox 33"/>
+          <p:cNvPr id="36" name="TextBox 35"/>
           <p:cNvSpPr txBox="1"/>
           <p:nvPr/>
         </p:nvSpPr>
@@ -4971,7 +4979,7 @@
       </p:sp>
       <p:sp>
         <p:nvSpPr>
-          <p:cNvPr id="35" name="Rounded Rectangle 34"/>
+          <p:cNvPr id="37" name="Rounded Rectangle 36"/>
           <p:cNvSpPr/>
           <p:nvPr/>
         </p:nvSpPr>
@@ -5015,7 +5023,7 @@
       </p:sp>
       <p:sp>
         <p:nvSpPr>
-          <p:cNvPr id="36" name="TextBox 35"/>
+          <p:cNvPr id="38" name="TextBox 37"/>
           <p:cNvSpPr txBox="1"/>
           <p:nvPr/>
         </p:nvSpPr>
@@ -5054,7 +5062,7 @@
       </p:sp>
       <p:sp>
         <p:nvSpPr>
-          <p:cNvPr id="37" name="TextBox 36"/>
+          <p:cNvPr id="39" name="TextBox 38"/>
           <p:cNvSpPr txBox="1"/>
           <p:nvPr/>
         </p:nvSpPr>
@@ -5093,7 +5101,7 @@
       </p:sp>
       <p:sp>
         <p:nvSpPr>
-          <p:cNvPr id="38" name="Rounded Rectangle 37"/>
+          <p:cNvPr id="40" name="Rounded Rectangle 39"/>
           <p:cNvSpPr/>
           <p:nvPr/>
         </p:nvSpPr>
@@ -5139,7 +5147,7 @@
       </p:sp>
       <p:sp>
         <p:nvSpPr>
-          <p:cNvPr id="39" name="TextBox 38"/>
+          <p:cNvPr id="41" name="TextBox 40"/>
           <p:cNvSpPr txBox="1"/>
           <p:nvPr/>
         </p:nvSpPr>
@@ -5214,7 +5222,7 @@
       </p:sp>
       <p:sp>
         <p:nvSpPr>
-          <p:cNvPr id="40" name="TextBox 39"/>
+          <p:cNvPr id="42" name="TextBox 41"/>
           <p:cNvSpPr txBox="1"/>
           <p:nvPr/>
         </p:nvSpPr>
@@ -5271,7 +5279,7 @@
       </p:sp>
       <p:sp>
         <p:nvSpPr>
-          <p:cNvPr id="41" name="TextBox 40"/>
+          <p:cNvPr id="43" name="TextBox 42"/>
           <p:cNvSpPr txBox="1"/>
           <p:nvPr/>
         </p:nvSpPr>
@@ -5696,8 +5704,8 @@
         </p:nvSpPr>
         <p:spPr>
           <a:xfrm>
-            <a:off x="548640" y="1901952"/>
-            <a:ext cx="2788920" cy="1005840"/>
+            <a:off x="548640" y="1874519"/>
+            <a:ext cx="2788920" cy="877824"/>
           </a:xfrm>
           <a:prstGeom prst="roundRect">
             <a:avLst/>
@@ -5742,8 +5750,8 @@
         </p:nvSpPr>
         <p:spPr>
           <a:xfrm>
-            <a:off x="548640" y="1901952"/>
-            <a:ext cx="82296" cy="1005840"/>
+            <a:off x="694944" y="2020823"/>
+            <a:ext cx="274320" cy="274320"/>
           </a:xfrm>
           <a:prstGeom prst="roundRect">
             <a:avLst/>
@@ -5778,16 +5786,40 @@
           </a:p>
         </p:txBody>
       </p:sp>
-      <p:sp>
-        <p:nvSpPr>
-          <p:cNvPr id="12" name="TextBox 11"/>
+      <p:pic>
+        <p:nvPicPr>
+          <p:cNvPr id="12" name="Picture 11" descr="target.png"/>
+          <p:cNvPicPr>
+            <a:picLocks noChangeAspect="1"/>
+          </p:cNvPicPr>
+          <p:nvPr/>
+        </p:nvPicPr>
+        <p:blipFill>
+          <a:blip r:embed="rId2"/>
+          <a:stretch>
+            <a:fillRect/>
+          </a:stretch>
+        </p:blipFill>
+        <p:spPr>
+          <a:xfrm>
+            <a:off x="744321" y="2070200"/>
+            <a:ext cx="175566" cy="175566"/>
+          </a:xfrm>
+          <a:prstGeom prst="rect">
+            <a:avLst/>
+          </a:prstGeom>
+        </p:spPr>
+      </p:pic>
+      <p:sp>
+        <p:nvSpPr>
+          <p:cNvPr id="13" name="TextBox 12"/>
           <p:cNvSpPr txBox="1"/>
           <p:nvPr/>
         </p:nvSpPr>
         <p:spPr>
           <a:xfrm>
-            <a:off x="768096" y="2011680"/>
-            <a:ext cx="2487168" cy="457200"/>
+            <a:off x="1078992" y="1984247"/>
+            <a:ext cx="2194560" cy="384048"/>
           </a:xfrm>
           <a:prstGeom prst="rect">
             <a:avLst/>
@@ -5806,7 +5838,7 @@
               </a:lnSpc>
             </a:pPr>
             <a:r>
-              <a:rPr sz="1150" b="1">
+              <a:rPr sz="1100" b="1">
                 <a:solidFill>
                   <a:srgbClr val="16273C"/>
                 </a:solidFill>
@@ -5819,14 +5851,14 @@
       </p:sp>
       <p:sp>
         <p:nvSpPr>
-          <p:cNvPr id="13" name="TextBox 12"/>
+          <p:cNvPr id="14" name="TextBox 13"/>
           <p:cNvSpPr txBox="1"/>
           <p:nvPr/>
         </p:nvSpPr>
         <p:spPr>
           <a:xfrm>
-            <a:off x="768096" y="2450592"/>
-            <a:ext cx="2487168" cy="420624"/>
+            <a:off x="694944" y="2386583"/>
+            <a:ext cx="2542032" cy="329184"/>
           </a:xfrm>
           <a:prstGeom prst="rect">
             <a:avLst/>
@@ -5841,11 +5873,11 @@
           <a:p>
             <a:pPr algn="l">
               <a:lnSpc>
-                <a:spcPct val="100000"/>
+                <a:spcPct val="98000"/>
               </a:lnSpc>
             </a:pPr>
             <a:r>
-              <a:rPr sz="950" b="0">
+              <a:rPr sz="900" b="0">
                 <a:solidFill>
                   <a:srgbClr val="556477"/>
                 </a:solidFill>
@@ -5858,14 +5890,14 @@
       </p:sp>
       <p:sp>
         <p:nvSpPr>
-          <p:cNvPr id="14" name="Rounded Rectangle 13"/>
+          <p:cNvPr id="15" name="Rounded Rectangle 14"/>
           <p:cNvSpPr/>
           <p:nvPr/>
         </p:nvSpPr>
         <p:spPr>
           <a:xfrm>
-            <a:off x="3465576" y="1901952"/>
-            <a:ext cx="2788920" cy="1005840"/>
+            <a:off x="3465576" y="1874519"/>
+            <a:ext cx="2788920" cy="877824"/>
           </a:xfrm>
           <a:prstGeom prst="roundRect">
             <a:avLst/>
@@ -5904,14 +5936,14 @@
       </p:sp>
       <p:sp>
         <p:nvSpPr>
-          <p:cNvPr id="15" name="Rounded Rectangle 14"/>
+          <p:cNvPr id="16" name="Rounded Rectangle 15"/>
           <p:cNvSpPr/>
           <p:nvPr/>
         </p:nvSpPr>
         <p:spPr>
           <a:xfrm>
-            <a:off x="3465576" y="1901952"/>
-            <a:ext cx="82296" cy="1005840"/>
+            <a:off x="3611880" y="2020823"/>
+            <a:ext cx="274320" cy="274320"/>
           </a:xfrm>
           <a:prstGeom prst="roundRect">
             <a:avLst/>
@@ -5946,16 +5978,40 @@
           </a:p>
         </p:txBody>
       </p:sp>
-      <p:sp>
-        <p:nvSpPr>
-          <p:cNvPr id="16" name="TextBox 15"/>
+      <p:pic>
+        <p:nvPicPr>
+          <p:cNvPr id="17" name="Picture 16" descr="scale.png"/>
+          <p:cNvPicPr>
+            <a:picLocks noChangeAspect="1"/>
+          </p:cNvPicPr>
+          <p:nvPr/>
+        </p:nvPicPr>
+        <p:blipFill>
+          <a:blip r:embed="rId3"/>
+          <a:stretch>
+            <a:fillRect/>
+          </a:stretch>
+        </p:blipFill>
+        <p:spPr>
+          <a:xfrm>
+            <a:off x="3661257" y="2070200"/>
+            <a:ext cx="175566" cy="175566"/>
+          </a:xfrm>
+          <a:prstGeom prst="rect">
+            <a:avLst/>
+          </a:prstGeom>
+        </p:spPr>
+      </p:pic>
+      <p:sp>
+        <p:nvSpPr>
+          <p:cNvPr id="18" name="TextBox 17"/>
           <p:cNvSpPr txBox="1"/>
           <p:nvPr/>
         </p:nvSpPr>
         <p:spPr>
           <a:xfrm>
-            <a:off x="3685032" y="2011680"/>
-            <a:ext cx="2487168" cy="457200"/>
+            <a:off x="3995928" y="1984247"/>
+            <a:ext cx="2194560" cy="384048"/>
           </a:xfrm>
           <a:prstGeom prst="rect">
             <a:avLst/>
@@ -5974,7 +6030,7 @@
               </a:lnSpc>
             </a:pPr>
             <a:r>
-              <a:rPr sz="1150" b="1">
+              <a:rPr sz="1100" b="1">
                 <a:solidFill>
                   <a:srgbClr val="16273C"/>
                 </a:solidFill>
@@ -5987,14 +6043,14 @@
       </p:sp>
       <p:sp>
         <p:nvSpPr>
-          <p:cNvPr id="17" name="TextBox 16"/>
+          <p:cNvPr id="19" name="TextBox 18"/>
           <p:cNvSpPr txBox="1"/>
           <p:nvPr/>
         </p:nvSpPr>
         <p:spPr>
           <a:xfrm>
-            <a:off x="3685032" y="2450592"/>
-            <a:ext cx="2487168" cy="420624"/>
+            <a:off x="3611880" y="2386583"/>
+            <a:ext cx="2542032" cy="329184"/>
           </a:xfrm>
           <a:prstGeom prst="rect">
             <a:avLst/>
@@ -6009,11 +6065,11 @@
           <a:p>
             <a:pPr algn="l">
               <a:lnSpc>
-                <a:spcPct val="100000"/>
+                <a:spcPct val="98000"/>
               </a:lnSpc>
             </a:pPr>
             <a:r>
-              <a:rPr sz="950" b="0">
+              <a:rPr sz="900" b="0">
                 <a:solidFill>
                   <a:srgbClr val="556477"/>
                 </a:solidFill>
@@ -6026,14 +6082,14 @@
       </p:sp>
       <p:sp>
         <p:nvSpPr>
-          <p:cNvPr id="18" name="Rounded Rectangle 17"/>
+          <p:cNvPr id="20" name="Rounded Rectangle 19"/>
           <p:cNvSpPr/>
           <p:nvPr/>
         </p:nvSpPr>
         <p:spPr>
           <a:xfrm>
-            <a:off x="6382512" y="1901952"/>
-            <a:ext cx="2788920" cy="1005840"/>
+            <a:off x="6382512" y="1874519"/>
+            <a:ext cx="2788920" cy="877824"/>
           </a:xfrm>
           <a:prstGeom prst="roundRect">
             <a:avLst/>
@@ -6072,14 +6128,14 @@
       </p:sp>
       <p:sp>
         <p:nvSpPr>
-          <p:cNvPr id="19" name="Rounded Rectangle 18"/>
+          <p:cNvPr id="21" name="Rounded Rectangle 20"/>
           <p:cNvSpPr/>
           <p:nvPr/>
         </p:nvSpPr>
         <p:spPr>
           <a:xfrm>
-            <a:off x="6382512" y="1901952"/>
-            <a:ext cx="82296" cy="1005840"/>
+            <a:off x="6528816" y="2020823"/>
+            <a:ext cx="274320" cy="274320"/>
           </a:xfrm>
           <a:prstGeom prst="roundRect">
             <a:avLst/>
@@ -6114,16 +6170,40 @@
           </a:p>
         </p:txBody>
       </p:sp>
-      <p:sp>
-        <p:nvSpPr>
-          <p:cNvPr id="20" name="TextBox 19"/>
+      <p:pic>
+        <p:nvPicPr>
+          <p:cNvPr id="22" name="Picture 21" descr="network.png"/>
+          <p:cNvPicPr>
+            <a:picLocks noChangeAspect="1"/>
+          </p:cNvPicPr>
+          <p:nvPr/>
+        </p:nvPicPr>
+        <p:blipFill>
+          <a:blip r:embed="rId4"/>
+          <a:stretch>
+            <a:fillRect/>
+          </a:stretch>
+        </p:blipFill>
+        <p:spPr>
+          <a:xfrm>
+            <a:off x="6578193" y="2070200"/>
+            <a:ext cx="175566" cy="175566"/>
+          </a:xfrm>
+          <a:prstGeom prst="rect">
+            <a:avLst/>
+          </a:prstGeom>
+        </p:spPr>
+      </p:pic>
+      <p:sp>
+        <p:nvSpPr>
+          <p:cNvPr id="23" name="TextBox 22"/>
           <p:cNvSpPr txBox="1"/>
           <p:nvPr/>
         </p:nvSpPr>
         <p:spPr>
           <a:xfrm>
-            <a:off x="6601968" y="2011680"/>
-            <a:ext cx="2487168" cy="457200"/>
+            <a:off x="6912864" y="1984247"/>
+            <a:ext cx="2194560" cy="384048"/>
           </a:xfrm>
           <a:prstGeom prst="rect">
             <a:avLst/>
@@ -6142,7 +6222,7 @@
               </a:lnSpc>
             </a:pPr>
             <a:r>
-              <a:rPr sz="1150" b="1">
+              <a:rPr sz="1100" b="1">
                 <a:solidFill>
                   <a:srgbClr val="16273C"/>
                 </a:solidFill>
@@ -6155,14 +6235,14 @@
       </p:sp>
       <p:sp>
         <p:nvSpPr>
-          <p:cNvPr id="21" name="TextBox 20"/>
+          <p:cNvPr id="24" name="TextBox 23"/>
           <p:cNvSpPr txBox="1"/>
           <p:nvPr/>
         </p:nvSpPr>
         <p:spPr>
           <a:xfrm>
-            <a:off x="6601968" y="2450592"/>
-            <a:ext cx="2487168" cy="420624"/>
+            <a:off x="6528816" y="2386583"/>
+            <a:ext cx="2542032" cy="329184"/>
           </a:xfrm>
           <a:prstGeom prst="rect">
             <a:avLst/>
@@ -6177,11 +6257,11 @@
           <a:p>
             <a:pPr algn="l">
               <a:lnSpc>
-                <a:spcPct val="100000"/>
+                <a:spcPct val="98000"/>
               </a:lnSpc>
             </a:pPr>
             <a:r>
-              <a:rPr sz="950" b="0">
+              <a:rPr sz="900" b="0">
                 <a:solidFill>
                   <a:srgbClr val="556477"/>
                 </a:solidFill>
@@ -6194,14 +6274,14 @@
       </p:sp>
       <p:sp>
         <p:nvSpPr>
-          <p:cNvPr id="22" name="Rounded Rectangle 21"/>
+          <p:cNvPr id="25" name="Rounded Rectangle 24"/>
           <p:cNvSpPr/>
           <p:nvPr/>
         </p:nvSpPr>
         <p:spPr>
           <a:xfrm>
-            <a:off x="9299448" y="1901952"/>
-            <a:ext cx="2788920" cy="1005840"/>
+            <a:off x="9299448" y="1874519"/>
+            <a:ext cx="2788920" cy="877824"/>
           </a:xfrm>
           <a:prstGeom prst="roundRect">
             <a:avLst/>
@@ -6240,14 +6320,14 @@
       </p:sp>
       <p:sp>
         <p:nvSpPr>
-          <p:cNvPr id="23" name="Rounded Rectangle 22"/>
+          <p:cNvPr id="26" name="Rounded Rectangle 25"/>
           <p:cNvSpPr/>
           <p:nvPr/>
         </p:nvSpPr>
         <p:spPr>
           <a:xfrm>
-            <a:off x="9299448" y="1901952"/>
-            <a:ext cx="82296" cy="1005840"/>
+            <a:off x="9445752" y="2020823"/>
+            <a:ext cx="274320" cy="274320"/>
           </a:xfrm>
           <a:prstGeom prst="roundRect">
             <a:avLst/>
@@ -6282,16 +6362,40 @@
           </a:p>
         </p:txBody>
       </p:sp>
-      <p:sp>
-        <p:nvSpPr>
-          <p:cNvPr id="24" name="TextBox 23"/>
+      <p:pic>
+        <p:nvPicPr>
+          <p:cNvPr id="27" name="Picture 26" descr="boxes.png"/>
+          <p:cNvPicPr>
+            <a:picLocks noChangeAspect="1"/>
+          </p:cNvPicPr>
+          <p:nvPr/>
+        </p:nvPicPr>
+        <p:blipFill>
+          <a:blip r:embed="rId5"/>
+          <a:stretch>
+            <a:fillRect/>
+          </a:stretch>
+        </p:blipFill>
+        <p:spPr>
+          <a:xfrm>
+            <a:off x="9495129" y="2070200"/>
+            <a:ext cx="175566" cy="175566"/>
+          </a:xfrm>
+          <a:prstGeom prst="rect">
+            <a:avLst/>
+          </a:prstGeom>
+        </p:spPr>
+      </p:pic>
+      <p:sp>
+        <p:nvSpPr>
+          <p:cNvPr id="28" name="TextBox 27"/>
           <p:cNvSpPr txBox="1"/>
           <p:nvPr/>
         </p:nvSpPr>
         <p:spPr>
           <a:xfrm>
-            <a:off x="9518904" y="2011680"/>
-            <a:ext cx="2487168" cy="457200"/>
+            <a:off x="9829800" y="1984247"/>
+            <a:ext cx="2194560" cy="384048"/>
           </a:xfrm>
           <a:prstGeom prst="rect">
             <a:avLst/>
@@ -6310,7 +6414,7 @@
               </a:lnSpc>
             </a:pPr>
             <a:r>
-              <a:rPr sz="1150" b="1">
+              <a:rPr sz="1100" b="1">
                 <a:solidFill>
                   <a:srgbClr val="16273C"/>
                 </a:solidFill>
@@ -6323,14 +6427,14 @@
       </p:sp>
       <p:sp>
         <p:nvSpPr>
-          <p:cNvPr id="25" name="TextBox 24"/>
+          <p:cNvPr id="29" name="TextBox 28"/>
           <p:cNvSpPr txBox="1"/>
           <p:nvPr/>
         </p:nvSpPr>
         <p:spPr>
           <a:xfrm>
-            <a:off x="9518904" y="2450592"/>
-            <a:ext cx="2487168" cy="420624"/>
+            <a:off x="9445752" y="2386583"/>
+            <a:ext cx="2542032" cy="329184"/>
           </a:xfrm>
           <a:prstGeom prst="rect">
             <a:avLst/>
@@ -6345,11 +6449,11 @@
           <a:p>
             <a:pPr algn="l">
               <a:lnSpc>
-                <a:spcPct val="100000"/>
+                <a:spcPct val="98000"/>
               </a:lnSpc>
             </a:pPr>
             <a:r>
-              <a:rPr sz="950" b="0">
+              <a:rPr sz="900" b="0">
                 <a:solidFill>
                   <a:srgbClr val="556477"/>
                 </a:solidFill>
@@ -6362,14 +6466,14 @@
       </p:sp>
       <p:sp>
         <p:nvSpPr>
-          <p:cNvPr id="26" name="Rounded Rectangle 25"/>
+          <p:cNvPr id="30" name="Rounded Rectangle 29"/>
           <p:cNvSpPr/>
           <p:nvPr/>
         </p:nvSpPr>
         <p:spPr>
           <a:xfrm>
-            <a:off x="548640" y="3035808"/>
-            <a:ext cx="2788920" cy="1005840"/>
+            <a:off x="548640" y="2862071"/>
+            <a:ext cx="2788920" cy="877824"/>
           </a:xfrm>
           <a:prstGeom prst="roundRect">
             <a:avLst/>
@@ -6408,14 +6512,14 @@
       </p:sp>
       <p:sp>
         <p:nvSpPr>
-          <p:cNvPr id="27" name="Rounded Rectangle 26"/>
+          <p:cNvPr id="31" name="Rounded Rectangle 30"/>
           <p:cNvSpPr/>
           <p:nvPr/>
         </p:nvSpPr>
         <p:spPr>
           <a:xfrm>
-            <a:off x="548640" y="3035808"/>
-            <a:ext cx="82296" cy="1005840"/>
+            <a:off x="694944" y="3008375"/>
+            <a:ext cx="274320" cy="274320"/>
           </a:xfrm>
           <a:prstGeom prst="roundRect">
             <a:avLst/>
@@ -6450,16 +6554,40 @@
           </a:p>
         </p:txBody>
       </p:sp>
-      <p:sp>
-        <p:nvSpPr>
-          <p:cNvPr id="28" name="TextBox 27"/>
+      <p:pic>
+        <p:nvPicPr>
+          <p:cNvPr id="32" name="Picture 31" descr="crosshair.png"/>
+          <p:cNvPicPr>
+            <a:picLocks noChangeAspect="1"/>
+          </p:cNvPicPr>
+          <p:nvPr/>
+        </p:nvPicPr>
+        <p:blipFill>
+          <a:blip r:embed="rId6"/>
+          <a:stretch>
+            <a:fillRect/>
+          </a:stretch>
+        </p:blipFill>
+        <p:spPr>
+          <a:xfrm>
+            <a:off x="744321" y="3057752"/>
+            <a:ext cx="175566" cy="175566"/>
+          </a:xfrm>
+          <a:prstGeom prst="rect">
+            <a:avLst/>
+          </a:prstGeom>
+        </p:spPr>
+      </p:pic>
+      <p:sp>
+        <p:nvSpPr>
+          <p:cNvPr id="33" name="TextBox 32"/>
           <p:cNvSpPr txBox="1"/>
           <p:nvPr/>
         </p:nvSpPr>
         <p:spPr>
           <a:xfrm>
-            <a:off x="768096" y="3145536"/>
-            <a:ext cx="2487168" cy="457200"/>
+            <a:off x="1078992" y="2971799"/>
+            <a:ext cx="2194560" cy="384048"/>
           </a:xfrm>
           <a:prstGeom prst="rect">
             <a:avLst/>
@@ -6478,7 +6606,7 @@
               </a:lnSpc>
             </a:pPr>
             <a:r>
-              <a:rPr sz="1150" b="1">
+              <a:rPr sz="1100" b="1">
                 <a:solidFill>
                   <a:srgbClr val="16273C"/>
                 </a:solidFill>
@@ -6491,14 +6619,14 @@
       </p:sp>
       <p:sp>
         <p:nvSpPr>
-          <p:cNvPr id="29" name="TextBox 28"/>
+          <p:cNvPr id="34" name="TextBox 33"/>
           <p:cNvSpPr txBox="1"/>
           <p:nvPr/>
         </p:nvSpPr>
         <p:spPr>
           <a:xfrm>
-            <a:off x="768096" y="3584448"/>
-            <a:ext cx="2487168" cy="420624"/>
+            <a:off x="694944" y="3374135"/>
+            <a:ext cx="2542032" cy="329184"/>
           </a:xfrm>
           <a:prstGeom prst="rect">
             <a:avLst/>
@@ -6513,11 +6641,11 @@
           <a:p>
             <a:pPr algn="l">
               <a:lnSpc>
-                <a:spcPct val="100000"/>
+                <a:spcPct val="98000"/>
               </a:lnSpc>
             </a:pPr>
             <a:r>
-              <a:rPr sz="950" b="0">
+              <a:rPr sz="900" b="0">
                 <a:solidFill>
                   <a:srgbClr val="556477"/>
                 </a:solidFill>
@@ -6530,14 +6658,14 @@
       </p:sp>
       <p:sp>
         <p:nvSpPr>
-          <p:cNvPr id="30" name="Rounded Rectangle 29"/>
+          <p:cNvPr id="35" name="Rounded Rectangle 34"/>
           <p:cNvSpPr/>
           <p:nvPr/>
         </p:nvSpPr>
         <p:spPr>
           <a:xfrm>
-            <a:off x="3465576" y="3035808"/>
-            <a:ext cx="2788920" cy="1005840"/>
+            <a:off x="3465576" y="2862071"/>
+            <a:ext cx="2788920" cy="877824"/>
           </a:xfrm>
           <a:prstGeom prst="roundRect">
             <a:avLst/>
@@ -6576,14 +6704,14 @@
       </p:sp>
       <p:sp>
         <p:nvSpPr>
-          <p:cNvPr id="31" name="Rounded Rectangle 30"/>
+          <p:cNvPr id="36" name="Rounded Rectangle 35"/>
           <p:cNvSpPr/>
           <p:nvPr/>
         </p:nvSpPr>
         <p:spPr>
           <a:xfrm>
-            <a:off x="3465576" y="3035808"/>
-            <a:ext cx="82296" cy="1005840"/>
+            <a:off x="3611880" y="3008375"/>
+            <a:ext cx="274320" cy="274320"/>
           </a:xfrm>
           <a:prstGeom prst="roundRect">
             <a:avLst/>
@@ -6618,16 +6746,40 @@
           </a:p>
         </p:txBody>
       </p:sp>
-      <p:sp>
-        <p:nvSpPr>
-          <p:cNvPr id="32" name="TextBox 31"/>
+      <p:pic>
+        <p:nvPicPr>
+          <p:cNvPr id="37" name="Picture 36" descr="sliders.png"/>
+          <p:cNvPicPr>
+            <a:picLocks noChangeAspect="1"/>
+          </p:cNvPicPr>
+          <p:nvPr/>
+        </p:nvPicPr>
+        <p:blipFill>
+          <a:blip r:embed="rId7"/>
+          <a:stretch>
+            <a:fillRect/>
+          </a:stretch>
+        </p:blipFill>
+        <p:spPr>
+          <a:xfrm>
+            <a:off x="3661257" y="3057752"/>
+            <a:ext cx="175566" cy="175566"/>
+          </a:xfrm>
+          <a:prstGeom prst="rect">
+            <a:avLst/>
+          </a:prstGeom>
+        </p:spPr>
+      </p:pic>
+      <p:sp>
+        <p:nvSpPr>
+          <p:cNvPr id="38" name="TextBox 37"/>
           <p:cNvSpPr txBox="1"/>
           <p:nvPr/>
         </p:nvSpPr>
         <p:spPr>
           <a:xfrm>
-            <a:off x="3685032" y="3145536"/>
-            <a:ext cx="2487168" cy="457200"/>
+            <a:off x="3995928" y="2971799"/>
+            <a:ext cx="2194560" cy="384048"/>
           </a:xfrm>
           <a:prstGeom prst="rect">
             <a:avLst/>
@@ -6646,7 +6798,7 @@
               </a:lnSpc>
             </a:pPr>
             <a:r>
-              <a:rPr sz="1150" b="1">
+              <a:rPr sz="1100" b="1">
                 <a:solidFill>
                   <a:srgbClr val="16273C"/>
                 </a:solidFill>
@@ -6659,14 +6811,14 @@
       </p:sp>
       <p:sp>
         <p:nvSpPr>
-          <p:cNvPr id="33" name="TextBox 32"/>
+          <p:cNvPr id="39" name="TextBox 38"/>
           <p:cNvSpPr txBox="1"/>
           <p:nvPr/>
         </p:nvSpPr>
         <p:spPr>
           <a:xfrm>
-            <a:off x="3685032" y="3584448"/>
-            <a:ext cx="2487168" cy="420624"/>
+            <a:off x="3611880" y="3374135"/>
+            <a:ext cx="2542032" cy="329184"/>
           </a:xfrm>
           <a:prstGeom prst="rect">
             <a:avLst/>
@@ -6681,31 +6833,31 @@
           <a:p>
             <a:pPr algn="l">
               <a:lnSpc>
-                <a:spcPct val="100000"/>
+                <a:spcPct val="98000"/>
               </a:lnSpc>
             </a:pPr>
             <a:r>
-              <a:rPr sz="950" b="0">
+              <a:rPr sz="900" b="0">
                 <a:solidFill>
                   <a:srgbClr val="556477"/>
                 </a:solidFill>
                 <a:latin typeface="Segoe UI"/>
               </a:rPr>
-              <a:t>Engine-costed relaxations · CTQs locked in code</a:t>
-            </a:r>
-          </a:p>
-        </p:txBody>
-      </p:sp>
-      <p:sp>
-        <p:nvSpPr>
-          <p:cNvPr id="34" name="Rounded Rectangle 33"/>
+              <a:t>Engine-costed relaxations · CTQs locked</a:t>
+            </a:r>
+          </a:p>
+        </p:txBody>
+      </p:sp>
+      <p:sp>
+        <p:nvSpPr>
+          <p:cNvPr id="40" name="Rounded Rectangle 39"/>
           <p:cNvSpPr/>
           <p:nvPr/>
         </p:nvSpPr>
         <p:spPr>
           <a:xfrm>
-            <a:off x="6382512" y="3035808"/>
-            <a:ext cx="2788920" cy="1005840"/>
+            <a:off x="6382512" y="2862071"/>
+            <a:ext cx="2788920" cy="877824"/>
           </a:xfrm>
           <a:prstGeom prst="roundRect">
             <a:avLst/>
@@ -6744,14 +6896,14 @@
       </p:sp>
       <p:sp>
         <p:nvSpPr>
-          <p:cNvPr id="35" name="Rounded Rectangle 34"/>
+          <p:cNvPr id="41" name="Rounded Rectangle 40"/>
           <p:cNvSpPr/>
           <p:nvPr/>
         </p:nvSpPr>
         <p:spPr>
           <a:xfrm>
-            <a:off x="6382512" y="3035808"/>
-            <a:ext cx="82296" cy="1005840"/>
+            <a:off x="6528816" y="3008375"/>
+            <a:ext cx="274320" cy="274320"/>
           </a:xfrm>
           <a:prstGeom prst="roundRect">
             <a:avLst/>
@@ -6786,16 +6938,40 @@
           </a:p>
         </p:txBody>
       </p:sp>
-      <p:sp>
-        <p:nvSpPr>
-          <p:cNvPr id="36" name="TextBox 35"/>
+      <p:pic>
+        <p:nvPicPr>
+          <p:cNvPr id="42" name="Picture 41" descr="compare.png"/>
+          <p:cNvPicPr>
+            <a:picLocks noChangeAspect="1"/>
+          </p:cNvPicPr>
+          <p:nvPr/>
+        </p:nvPicPr>
+        <p:blipFill>
+          <a:blip r:embed="rId8"/>
+          <a:stretch>
+            <a:fillRect/>
+          </a:stretch>
+        </p:blipFill>
+        <p:spPr>
+          <a:xfrm>
+            <a:off x="6578193" y="3057752"/>
+            <a:ext cx="175566" cy="175566"/>
+          </a:xfrm>
+          <a:prstGeom prst="rect">
+            <a:avLst/>
+          </a:prstGeom>
+        </p:spPr>
+      </p:pic>
+      <p:sp>
+        <p:nvSpPr>
+          <p:cNvPr id="43" name="TextBox 42"/>
           <p:cNvSpPr txBox="1"/>
           <p:nvPr/>
         </p:nvSpPr>
         <p:spPr>
           <a:xfrm>
-            <a:off x="6601968" y="3145536"/>
-            <a:ext cx="2487168" cy="457200"/>
+            <a:off x="6912864" y="2971799"/>
+            <a:ext cx="2194560" cy="384048"/>
           </a:xfrm>
           <a:prstGeom prst="rect">
             <a:avLst/>
@@ -6814,7 +6990,7 @@
               </a:lnSpc>
             </a:pPr>
             <a:r>
-              <a:rPr sz="1150" b="1">
+              <a:rPr sz="1100" b="1">
                 <a:solidFill>
                   <a:srgbClr val="16273C"/>
                 </a:solidFill>
@@ -6827,14 +7003,14 @@
       </p:sp>
       <p:sp>
         <p:nvSpPr>
-          <p:cNvPr id="37" name="TextBox 36"/>
+          <p:cNvPr id="44" name="TextBox 43"/>
           <p:cNvSpPr txBox="1"/>
           <p:nvPr/>
         </p:nvSpPr>
         <p:spPr>
           <a:xfrm>
-            <a:off x="6601968" y="3584448"/>
-            <a:ext cx="2487168" cy="420624"/>
+            <a:off x="6528816" y="3374135"/>
+            <a:ext cx="2542032" cy="329184"/>
           </a:xfrm>
           <a:prstGeom prst="rect">
             <a:avLst/>
@@ -6849,31 +7025,31 @@
           <a:p>
             <a:pPr algn="l">
               <a:lnSpc>
-                <a:spcPct val="100000"/>
+                <a:spcPct val="98000"/>
               </a:lnSpc>
             </a:pPr>
             <a:r>
-              <a:rPr sz="950" b="0">
+              <a:rPr sz="900" b="0">
                 <a:solidFill>
                   <a:srgbClr val="556477"/>
                 </a:solidFill>
                 <a:latin typeface="Segoe UI"/>
               </a:rPr>
-              <a:t>Attribute-by-attribute vs a benchmark part</a:t>
-            </a:r>
-          </a:p>
-        </p:txBody>
-      </p:sp>
-      <p:sp>
-        <p:nvSpPr>
-          <p:cNvPr id="38" name="Rounded Rectangle 37"/>
+              <a:t>Attribute-by-attribute vs a benchmark</a:t>
+            </a:r>
+          </a:p>
+        </p:txBody>
+      </p:sp>
+      <p:sp>
+        <p:nvSpPr>
+          <p:cNvPr id="45" name="Rounded Rectangle 44"/>
           <p:cNvSpPr/>
           <p:nvPr/>
         </p:nvSpPr>
         <p:spPr>
           <a:xfrm>
-            <a:off x="9299448" y="3035808"/>
-            <a:ext cx="2788920" cy="1005840"/>
+            <a:off x="9299448" y="2862071"/>
+            <a:ext cx="2788920" cy="877824"/>
           </a:xfrm>
           <a:prstGeom prst="roundRect">
             <a:avLst/>
@@ -6912,14 +7088,14 @@
       </p:sp>
       <p:sp>
         <p:nvSpPr>
-          <p:cNvPr id="39" name="Rounded Rectangle 38"/>
+          <p:cNvPr id="46" name="Rounded Rectangle 45"/>
           <p:cNvSpPr/>
           <p:nvPr/>
         </p:nvSpPr>
         <p:spPr>
           <a:xfrm>
-            <a:off x="9299448" y="3035808"/>
-            <a:ext cx="82296" cy="1005840"/>
+            <a:off x="9445752" y="3008375"/>
+            <a:ext cx="274320" cy="274320"/>
           </a:xfrm>
           <a:prstGeom prst="roundRect">
             <a:avLst/>
@@ -6954,16 +7130,40 @@
           </a:p>
         </p:txBody>
       </p:sp>
-      <p:sp>
-        <p:nvSpPr>
-          <p:cNvPr id="40" name="TextBox 39"/>
+      <p:pic>
+        <p:nvPicPr>
+          <p:cNvPr id="47" name="Picture 46" descr="shuffle.png"/>
+          <p:cNvPicPr>
+            <a:picLocks noChangeAspect="1"/>
+          </p:cNvPicPr>
+          <p:nvPr/>
+        </p:nvPicPr>
+        <p:blipFill>
+          <a:blip r:embed="rId9"/>
+          <a:stretch>
+            <a:fillRect/>
+          </a:stretch>
+        </p:blipFill>
+        <p:spPr>
+          <a:xfrm>
+            <a:off x="9495129" y="3057752"/>
+            <a:ext cx="175566" cy="175566"/>
+          </a:xfrm>
+          <a:prstGeom prst="rect">
+            <a:avLst/>
+          </a:prstGeom>
+        </p:spPr>
+      </p:pic>
+      <p:sp>
+        <p:nvSpPr>
+          <p:cNvPr id="48" name="TextBox 47"/>
           <p:cNvSpPr txBox="1"/>
           <p:nvPr/>
         </p:nvSpPr>
         <p:spPr>
           <a:xfrm>
-            <a:off x="9518904" y="3145536"/>
-            <a:ext cx="2487168" cy="457200"/>
+            <a:off x="9829800" y="2971799"/>
+            <a:ext cx="2194560" cy="384048"/>
           </a:xfrm>
           <a:prstGeom prst="rect">
             <a:avLst/>
@@ -6982,7 +7182,7 @@
               </a:lnSpc>
             </a:pPr>
             <a:r>
-              <a:rPr sz="1150" b="1">
+              <a:rPr sz="1100" b="1">
                 <a:solidFill>
                   <a:srgbClr val="16273C"/>
                 </a:solidFill>
@@ -6995,14 +7195,14 @@
       </p:sp>
       <p:sp>
         <p:nvSpPr>
-          <p:cNvPr id="41" name="TextBox 40"/>
+          <p:cNvPr id="49" name="TextBox 48"/>
           <p:cNvSpPr txBox="1"/>
           <p:nvPr/>
         </p:nvSpPr>
         <p:spPr>
           <a:xfrm>
-            <a:off x="9518904" y="3584448"/>
-            <a:ext cx="2487168" cy="420624"/>
+            <a:off x="9445752" y="3374135"/>
+            <a:ext cx="2542032" cy="329184"/>
           </a:xfrm>
           <a:prstGeom prst="rect">
             <a:avLst/>
@@ -7017,11 +7217,11 @@
           <a:p>
             <a:pPr algn="l">
               <a:lnSpc>
-                <a:spcPct val="100000"/>
+                <a:spcPct val="98000"/>
               </a:lnSpc>
             </a:pPr>
             <a:r>
-              <a:rPr sz="950" b="0">
+              <a:rPr sz="900" b="0">
                 <a:solidFill>
                   <a:srgbClr val="556477"/>
                 </a:solidFill>
@@ -7034,14 +7234,14 @@
       </p:sp>
       <p:sp>
         <p:nvSpPr>
-          <p:cNvPr id="42" name="Rounded Rectangle 41"/>
+          <p:cNvPr id="50" name="Rounded Rectangle 49"/>
           <p:cNvSpPr/>
           <p:nvPr/>
         </p:nvSpPr>
         <p:spPr>
           <a:xfrm>
-            <a:off x="548640" y="4169664"/>
-            <a:ext cx="2788920" cy="1005840"/>
+            <a:off x="548640" y="3849623"/>
+            <a:ext cx="2788920" cy="877824"/>
           </a:xfrm>
           <a:prstGeom prst="roundRect">
             <a:avLst/>
@@ -7080,14 +7280,14 @@
       </p:sp>
       <p:sp>
         <p:nvSpPr>
-          <p:cNvPr id="43" name="Rounded Rectangle 42"/>
+          <p:cNvPr id="51" name="Rounded Rectangle 50"/>
           <p:cNvSpPr/>
           <p:nvPr/>
         </p:nvSpPr>
         <p:spPr>
           <a:xfrm>
-            <a:off x="548640" y="4169664"/>
-            <a:ext cx="82296" cy="1005840"/>
+            <a:off x="694944" y="3995927"/>
+            <a:ext cx="274320" cy="274320"/>
           </a:xfrm>
           <a:prstGeom prst="roundRect">
             <a:avLst/>
@@ -7122,16 +7322,40 @@
           </a:p>
         </p:txBody>
       </p:sp>
-      <p:sp>
-        <p:nvSpPr>
-          <p:cNvPr id="44" name="TextBox 43"/>
+      <p:pic>
+        <p:nvPicPr>
+          <p:cNvPr id="52" name="Picture 51" descr="grid.png"/>
+          <p:cNvPicPr>
+            <a:picLocks noChangeAspect="1"/>
+          </p:cNvPicPr>
+          <p:nvPr/>
+        </p:nvPicPr>
+        <p:blipFill>
+          <a:blip r:embed="rId10"/>
+          <a:stretch>
+            <a:fillRect/>
+          </a:stretch>
+        </p:blipFill>
+        <p:spPr>
+          <a:xfrm>
+            <a:off x="744321" y="4045304"/>
+            <a:ext cx="175566" cy="175566"/>
+          </a:xfrm>
+          <a:prstGeom prst="rect">
+            <a:avLst/>
+          </a:prstGeom>
+        </p:spPr>
+      </p:pic>
+      <p:sp>
+        <p:nvSpPr>
+          <p:cNvPr id="53" name="TextBox 52"/>
           <p:cNvSpPr txBox="1"/>
           <p:nvPr/>
         </p:nvSpPr>
         <p:spPr>
           <a:xfrm>
-            <a:off x="768096" y="4279392"/>
-            <a:ext cx="2487168" cy="457200"/>
+            <a:off x="1078992" y="3959351"/>
+            <a:ext cx="2194560" cy="384048"/>
           </a:xfrm>
           <a:prstGeom prst="rect">
             <a:avLst/>
@@ -7150,7 +7374,7 @@
               </a:lnSpc>
             </a:pPr>
             <a:r>
-              <a:rPr sz="1150" b="1">
+              <a:rPr sz="1100" b="1">
                 <a:solidFill>
                   <a:srgbClr val="16273C"/>
                 </a:solidFill>
@@ -7163,14 +7387,14 @@
       </p:sp>
       <p:sp>
         <p:nvSpPr>
-          <p:cNvPr id="45" name="TextBox 44"/>
+          <p:cNvPr id="54" name="TextBox 53"/>
           <p:cNvSpPr txBox="1"/>
           <p:nvPr/>
         </p:nvSpPr>
         <p:spPr>
           <a:xfrm>
-            <a:off x="768096" y="4718304"/>
-            <a:ext cx="2487168" cy="420624"/>
+            <a:off x="694944" y="4361687"/>
+            <a:ext cx="2542032" cy="329184"/>
           </a:xfrm>
           <a:prstGeom prst="rect">
             <a:avLst/>
@@ -7185,11 +7409,11 @@
           <a:p>
             <a:pPr algn="l">
               <a:lnSpc>
-                <a:spcPct val="100000"/>
+                <a:spcPct val="98000"/>
               </a:lnSpc>
             </a:pPr>
             <a:r>
-              <a:rPr sz="950" b="0">
+              <a:rPr sz="900" b="0">
                 <a:solidFill>
                   <a:srgbClr val="556477"/>
                 </a:solidFill>
@@ -7202,14 +7426,14 @@
       </p:sp>
       <p:sp>
         <p:nvSpPr>
-          <p:cNvPr id="46" name="Rounded Rectangle 45"/>
+          <p:cNvPr id="55" name="Rounded Rectangle 54"/>
           <p:cNvSpPr/>
           <p:nvPr/>
         </p:nvSpPr>
         <p:spPr>
           <a:xfrm>
-            <a:off x="3465576" y="4169664"/>
-            <a:ext cx="2788920" cy="1005840"/>
+            <a:off x="3465576" y="3849623"/>
+            <a:ext cx="2788920" cy="877824"/>
           </a:xfrm>
           <a:prstGeom prst="roundRect">
             <a:avLst/>
@@ -7248,14 +7472,14 @@
       </p:sp>
       <p:sp>
         <p:nvSpPr>
-          <p:cNvPr id="47" name="Rounded Rectangle 46"/>
+          <p:cNvPr id="56" name="Rounded Rectangle 55"/>
           <p:cNvSpPr/>
           <p:nvPr/>
         </p:nvSpPr>
         <p:spPr>
           <a:xfrm>
-            <a:off x="3465576" y="4169664"/>
-            <a:ext cx="82296" cy="1005840"/>
+            <a:off x="3611880" y="3995927"/>
+            <a:ext cx="274320" cy="274320"/>
           </a:xfrm>
           <a:prstGeom prst="roundRect">
             <a:avLst/>
@@ -7290,16 +7514,40 @@
           </a:p>
         </p:txBody>
       </p:sp>
-      <p:sp>
-        <p:nvSpPr>
-          <p:cNvPr id="48" name="TextBox 47"/>
+      <p:pic>
+        <p:nvPicPr>
+          <p:cNvPr id="57" name="Picture 56" descr="zap.png"/>
+          <p:cNvPicPr>
+            <a:picLocks noChangeAspect="1"/>
+          </p:cNvPicPr>
+          <p:nvPr/>
+        </p:nvPicPr>
+        <p:blipFill>
+          <a:blip r:embed="rId11"/>
+          <a:stretch>
+            <a:fillRect/>
+          </a:stretch>
+        </p:blipFill>
+        <p:spPr>
+          <a:xfrm>
+            <a:off x="3661257" y="4045304"/>
+            <a:ext cx="175566" cy="175566"/>
+          </a:xfrm>
+          <a:prstGeom prst="rect">
+            <a:avLst/>
+          </a:prstGeom>
+        </p:spPr>
+      </p:pic>
+      <p:sp>
+        <p:nvSpPr>
+          <p:cNvPr id="58" name="TextBox 57"/>
           <p:cNvSpPr txBox="1"/>
           <p:nvPr/>
         </p:nvSpPr>
         <p:spPr>
           <a:xfrm>
-            <a:off x="3685032" y="4279392"/>
-            <a:ext cx="2487168" cy="457200"/>
+            <a:off x="3995928" y="3959351"/>
+            <a:ext cx="2194560" cy="384048"/>
           </a:xfrm>
           <a:prstGeom prst="rect">
             <a:avLst/>
@@ -7318,7 +7566,7 @@
               </a:lnSpc>
             </a:pPr>
             <a:r>
-              <a:rPr sz="1150" b="1">
+              <a:rPr sz="1100" b="1">
                 <a:solidFill>
                   <a:srgbClr val="16273C"/>
                 </a:solidFill>
@@ -7331,14 +7579,14 @@
       </p:sp>
       <p:sp>
         <p:nvSpPr>
-          <p:cNvPr id="49" name="TextBox 48"/>
+          <p:cNvPr id="59" name="TextBox 58"/>
           <p:cNvSpPr txBox="1"/>
           <p:nvPr/>
         </p:nvSpPr>
         <p:spPr>
           <a:xfrm>
-            <a:off x="3685032" y="4718304"/>
-            <a:ext cx="2487168" cy="420624"/>
+            <a:off x="3611880" y="4361687"/>
+            <a:ext cx="2542032" cy="329184"/>
           </a:xfrm>
           <a:prstGeom prst="rect">
             <a:avLst/>
@@ -7353,11 +7601,11 @@
           <a:p>
             <a:pPr algn="l">
               <a:lnSpc>
-                <a:spcPct val="100000"/>
+                <a:spcPct val="98000"/>
               </a:lnSpc>
             </a:pPr>
             <a:r>
-              <a:rPr sz="950" b="0">
+              <a:rPr sz="900" b="0">
                 <a:solidFill>
                   <a:srgbClr val="556477"/>
                 </a:solidFill>
@@ -7370,14 +7618,14 @@
       </p:sp>
       <p:sp>
         <p:nvSpPr>
-          <p:cNvPr id="50" name="Rounded Rectangle 49"/>
+          <p:cNvPr id="60" name="Rounded Rectangle 59"/>
           <p:cNvSpPr/>
           <p:nvPr/>
         </p:nvSpPr>
         <p:spPr>
           <a:xfrm>
-            <a:off x="6382512" y="4169664"/>
-            <a:ext cx="2788920" cy="1005840"/>
+            <a:off x="6382512" y="3849623"/>
+            <a:ext cx="2788920" cy="877824"/>
           </a:xfrm>
           <a:prstGeom prst="roundRect">
             <a:avLst/>
@@ -7416,14 +7664,14 @@
       </p:sp>
       <p:sp>
         <p:nvSpPr>
-          <p:cNvPr id="51" name="Rounded Rectangle 50"/>
+          <p:cNvPr id="61" name="Rounded Rectangle 60"/>
           <p:cNvSpPr/>
           <p:nvPr/>
         </p:nvSpPr>
         <p:spPr>
           <a:xfrm>
-            <a:off x="6382512" y="4169664"/>
-            <a:ext cx="82296" cy="1005840"/>
+            <a:off x="6528816" y="3995927"/>
+            <a:ext cx="274320" cy="274320"/>
           </a:xfrm>
           <a:prstGeom prst="roundRect">
             <a:avLst/>
@@ -7458,16 +7706,40 @@
           </a:p>
         </p:txBody>
       </p:sp>
-      <p:sp>
-        <p:nvSpPr>
-          <p:cNvPr id="52" name="TextBox 51"/>
+      <p:pic>
+        <p:nvPicPr>
+          <p:cNvPr id="62" name="Picture 61" descr="recycle.png"/>
+          <p:cNvPicPr>
+            <a:picLocks noChangeAspect="1"/>
+          </p:cNvPicPr>
+          <p:nvPr/>
+        </p:nvPicPr>
+        <p:blipFill>
+          <a:blip r:embed="rId12"/>
+          <a:stretch>
+            <a:fillRect/>
+          </a:stretch>
+        </p:blipFill>
+        <p:spPr>
+          <a:xfrm>
+            <a:off x="6578193" y="4045304"/>
+            <a:ext cx="175566" cy="175566"/>
+          </a:xfrm>
+          <a:prstGeom prst="rect">
+            <a:avLst/>
+          </a:prstGeom>
+        </p:spPr>
+      </p:pic>
+      <p:sp>
+        <p:nvSpPr>
+          <p:cNvPr id="63" name="TextBox 62"/>
           <p:cNvSpPr txBox="1"/>
           <p:nvPr/>
         </p:nvSpPr>
         <p:spPr>
           <a:xfrm>
-            <a:off x="6601968" y="4279392"/>
-            <a:ext cx="2487168" cy="457200"/>
+            <a:off x="6912864" y="3959351"/>
+            <a:ext cx="2194560" cy="384048"/>
           </a:xfrm>
           <a:prstGeom prst="rect">
             <a:avLst/>
@@ -7486,7 +7758,7 @@
               </a:lnSpc>
             </a:pPr>
             <a:r>
-              <a:rPr sz="1150" b="1">
+              <a:rPr sz="1100" b="1">
                 <a:solidFill>
                   <a:srgbClr val="16273C"/>
                 </a:solidFill>
@@ -7499,14 +7771,14 @@
       </p:sp>
       <p:sp>
         <p:nvSpPr>
-          <p:cNvPr id="53" name="TextBox 52"/>
+          <p:cNvPr id="64" name="TextBox 63"/>
           <p:cNvSpPr txBox="1"/>
           <p:nvPr/>
         </p:nvSpPr>
         <p:spPr>
           <a:xfrm>
-            <a:off x="6601968" y="4718304"/>
-            <a:ext cx="2487168" cy="420624"/>
+            <a:off x="6528816" y="4361687"/>
+            <a:ext cx="2542032" cy="329184"/>
           </a:xfrm>
           <a:prstGeom prst="rect">
             <a:avLst/>
@@ -7521,11 +7793,11 @@
           <a:p>
             <a:pPr algn="l">
               <a:lnSpc>
-                <a:spcPct val="100000"/>
+                <a:spcPct val="98000"/>
               </a:lnSpc>
             </a:pPr>
             <a:r>
-              <a:rPr sz="950" b="0">
+              <a:rPr sz="900" b="0">
                 <a:solidFill>
                   <a:srgbClr val="556477"/>
                 </a:solidFill>
@@ -7538,14 +7810,14 @@
       </p:sp>
       <p:sp>
         <p:nvSpPr>
-          <p:cNvPr id="54" name="Rounded Rectangle 53"/>
+          <p:cNvPr id="65" name="Rounded Rectangle 64"/>
           <p:cNvSpPr/>
           <p:nvPr/>
         </p:nvSpPr>
         <p:spPr>
           <a:xfrm>
-            <a:off x="9299448" y="4169664"/>
-            <a:ext cx="2788920" cy="1005840"/>
+            <a:off x="9299448" y="3849623"/>
+            <a:ext cx="2788920" cy="877824"/>
           </a:xfrm>
           <a:prstGeom prst="roundRect">
             <a:avLst/>
@@ -7584,14 +7856,14 @@
       </p:sp>
       <p:sp>
         <p:nvSpPr>
-          <p:cNvPr id="55" name="Rounded Rectangle 54"/>
+          <p:cNvPr id="66" name="Rounded Rectangle 65"/>
           <p:cNvSpPr/>
           <p:nvPr/>
         </p:nvSpPr>
         <p:spPr>
           <a:xfrm>
-            <a:off x="9299448" y="4169664"/>
-            <a:ext cx="82296" cy="1005840"/>
+            <a:off x="9445752" y="3995927"/>
+            <a:ext cx="274320" cy="274320"/>
           </a:xfrm>
           <a:prstGeom prst="roundRect">
             <a:avLst/>
@@ -7626,16 +7898,40 @@
           </a:p>
         </p:txBody>
       </p:sp>
-      <p:sp>
-        <p:nvSpPr>
-          <p:cNvPr id="56" name="TextBox 55"/>
+      <p:pic>
+        <p:nvPicPr>
+          <p:cNvPr id="67" name="Picture 66" descr="layers.png"/>
+          <p:cNvPicPr>
+            <a:picLocks noChangeAspect="1"/>
+          </p:cNvPicPr>
+          <p:nvPr/>
+        </p:nvPicPr>
+        <p:blipFill>
+          <a:blip r:embed="rId13"/>
+          <a:stretch>
+            <a:fillRect/>
+          </a:stretch>
+        </p:blipFill>
+        <p:spPr>
+          <a:xfrm>
+            <a:off x="9495129" y="4045304"/>
+            <a:ext cx="175566" cy="175566"/>
+          </a:xfrm>
+          <a:prstGeom prst="rect">
+            <a:avLst/>
+          </a:prstGeom>
+        </p:spPr>
+      </p:pic>
+      <p:sp>
+        <p:nvSpPr>
+          <p:cNvPr id="68" name="TextBox 67"/>
           <p:cNvSpPr txBox="1"/>
           <p:nvPr/>
         </p:nvSpPr>
         <p:spPr>
           <a:xfrm>
-            <a:off x="9518904" y="4279392"/>
-            <a:ext cx="2487168" cy="457200"/>
+            <a:off x="9829800" y="3959351"/>
+            <a:ext cx="2194560" cy="384048"/>
           </a:xfrm>
           <a:prstGeom prst="rect">
             <a:avLst/>
@@ -7654,7 +7950,7 @@
               </a:lnSpc>
             </a:pPr>
             <a:r>
-              <a:rPr sz="1150" b="1">
+              <a:rPr sz="1100" b="1">
                 <a:solidFill>
                   <a:srgbClr val="16273C"/>
                 </a:solidFill>
@@ -7667,14 +7963,14 @@
       </p:sp>
       <p:sp>
         <p:nvSpPr>
-          <p:cNvPr id="57" name="TextBox 56"/>
+          <p:cNvPr id="69" name="TextBox 68"/>
           <p:cNvSpPr txBox="1"/>
           <p:nvPr/>
         </p:nvSpPr>
         <p:spPr>
           <a:xfrm>
-            <a:off x="9518904" y="4718304"/>
-            <a:ext cx="2487168" cy="420624"/>
+            <a:off x="9445752" y="4361687"/>
+            <a:ext cx="2542032" cy="329184"/>
           </a:xfrm>
           <a:prstGeom prst="rect">
             <a:avLst/>
@@ -7689,31 +7985,31 @@
           <a:p>
             <a:pPr algn="l">
               <a:lnSpc>
-                <a:spcPct val="100000"/>
+                <a:spcPct val="98000"/>
               </a:lnSpc>
             </a:pPr>
             <a:r>
-              <a:rPr sz="950" b="0">
+              <a:rPr sz="900" b="0">
                 <a:solidFill>
                   <a:srgbClr val="556477"/>
                 </a:solidFill>
                 <a:latin typeface="Segoe UI"/>
               </a:rPr>
-              <a:t>Layer methods onto any analysis — incl. Biomimicry</a:t>
-            </a:r>
-          </a:p>
-        </p:txBody>
-      </p:sp>
-      <p:sp>
-        <p:nvSpPr>
-          <p:cNvPr id="58" name="Rounded Rectangle 57"/>
+              <a:t>Layer onto any analysis — incl. Biomimicry</a:t>
+            </a:r>
+          </a:p>
+        </p:txBody>
+      </p:sp>
+      <p:sp>
+        <p:nvSpPr>
+          <p:cNvPr id="70" name="Rounded Rectangle 69"/>
           <p:cNvSpPr/>
           <p:nvPr/>
         </p:nvSpPr>
         <p:spPr>
           <a:xfrm>
-            <a:off x="548640" y="5486400"/>
-            <a:ext cx="11091672" cy="713232"/>
+            <a:off x="548640" y="4983480"/>
+            <a:ext cx="5669280" cy="1188720"/>
           </a:xfrm>
           <a:prstGeom prst="roundRect">
             <a:avLst/>
@@ -7752,14 +8048,14 @@
       </p:sp>
       <p:sp>
         <p:nvSpPr>
-          <p:cNvPr id="59" name="Rounded Rectangle 58"/>
+          <p:cNvPr id="71" name="Rounded Rectangle 70"/>
           <p:cNvSpPr/>
           <p:nvPr/>
         </p:nvSpPr>
         <p:spPr>
           <a:xfrm>
-            <a:off x="548640" y="5486400"/>
-            <a:ext cx="109728" cy="713232"/>
+            <a:off x="749808" y="5102352"/>
+            <a:ext cx="274320" cy="274320"/>
           </a:xfrm>
           <a:prstGeom prst="roundRect">
             <a:avLst/>
@@ -7794,16 +8090,40 @@
           </a:p>
         </p:txBody>
       </p:sp>
-      <p:sp>
-        <p:nvSpPr>
-          <p:cNvPr id="60" name="TextBox 59"/>
+      <p:pic>
+        <p:nvPicPr>
+          <p:cNvPr id="72" name="Picture 71" descr="chart.png"/>
+          <p:cNvPicPr>
+            <a:picLocks noChangeAspect="1"/>
+          </p:cNvPicPr>
+          <p:nvPr/>
+        </p:nvPicPr>
+        <p:blipFill>
+          <a:blip r:embed="rId14"/>
+          <a:stretch>
+            <a:fillRect/>
+          </a:stretch>
+        </p:blipFill>
+        <p:spPr>
+          <a:xfrm>
+            <a:off x="799185" y="5151729"/>
+            <a:ext cx="175566" cy="175566"/>
+          </a:xfrm>
+          <a:prstGeom prst="rect">
+            <a:avLst/>
+          </a:prstGeom>
+        </p:spPr>
+      </p:pic>
+      <p:sp>
+        <p:nvSpPr>
+          <p:cNvPr id="73" name="TextBox 72"/>
           <p:cNvSpPr txBox="1"/>
           <p:nvPr/>
         </p:nvSpPr>
         <p:spPr>
           <a:xfrm>
-            <a:off x="868680" y="5577840"/>
-            <a:ext cx="10515600" cy="548640"/>
+            <a:off x="1133856" y="5120640"/>
+            <a:ext cx="4937760" cy="274320"/>
           </a:xfrm>
           <a:prstGeom prst="rect">
             <a:avLst/>
@@ -7811,51 +8131,760 @@
           <a:noFill/>
         </p:spPr>
         <p:txBody>
-          <a:bodyPr wrap="square" anchor="ctr" lIns="0" rIns="0" tIns="0" bIns="0">
+          <a:bodyPr wrap="square" anchor="t" lIns="0" rIns="0" tIns="0" bIns="0">
             <a:spAutoFit/>
           </a:bodyPr>
           <a:lstStyle/>
           <a:p>
             <a:pPr algn="l">
               <a:lnSpc>
-                <a:spcPct val="104000"/>
+                <a:spcPct val="100000"/>
               </a:lnSpc>
             </a:pPr>
             <a:r>
-              <a:rPr sz="1200" b="1">
-                <a:solidFill>
-                  <a:srgbClr val="0D9488"/>
+              <a:rPr sz="850" b="1">
+                <a:solidFill>
+                  <a:srgbClr val="8390A1"/>
                 </a:solidFill>
                 <a:latin typeface="Segoe UI Semibold"/>
               </a:rPr>
-              <a:t>Proof, not promises:  </a:t>
-            </a:r>
-            <a:r>
-              <a:rPr sz="1150" b="0">
+              <a:t>HELD-OUT ACCURACY — FEATURE-BASED VS MASS ESTIMATE (MAPE, lower is better)</a:t>
+            </a:r>
+          </a:p>
+        </p:txBody>
+      </p:sp>
+      <p:sp>
+        <p:nvSpPr>
+          <p:cNvPr id="74" name="TextBox 73"/>
+          <p:cNvSpPr txBox="1"/>
+          <p:nvPr/>
+        </p:nvSpPr>
+        <p:spPr>
+          <a:xfrm>
+            <a:off x="749808" y="5449824"/>
+            <a:ext cx="822960" cy="228600"/>
+          </a:xfrm>
+          <a:prstGeom prst="rect">
+            <a:avLst/>
+          </a:prstGeom>
+          <a:noFill/>
+        </p:spPr>
+        <p:txBody>
+          <a:bodyPr wrap="square" anchor="t" lIns="0" rIns="0" tIns="0" bIns="0">
+            <a:spAutoFit/>
+          </a:bodyPr>
+          <a:lstStyle/>
+          <a:p>
+            <a:pPr algn="l">
+              <a:lnSpc>
+                <a:spcPct val="100000"/>
+              </a:lnSpc>
+            </a:pPr>
+            <a:r>
+              <a:rPr sz="900" b="1">
                 <a:solidFill>
                   <a:srgbClr val="374558"/>
+                </a:solidFill>
+                <a:latin typeface="Segoe UI Semibold"/>
+              </a:rPr>
+              <a:t>Machining</a:t>
+            </a:r>
+          </a:p>
+        </p:txBody>
+      </p:sp>
+      <p:sp>
+        <p:nvSpPr>
+          <p:cNvPr id="75" name="Rounded Rectangle 74"/>
+          <p:cNvSpPr/>
+          <p:nvPr/>
+        </p:nvSpPr>
+        <p:spPr>
+          <a:xfrm>
+            <a:off x="1600200" y="5440680"/>
+            <a:ext cx="1798167" cy="105156"/>
+          </a:xfrm>
+          <a:prstGeom prst="roundRect">
+            <a:avLst/>
+          </a:prstGeom>
+          <a:solidFill>
+            <a:srgbClr val="8390A1"/>
+          </a:solidFill>
+          <a:ln>
+            <a:noFill/>
+          </a:ln>
+          <a:effectLst/>
+        </p:spPr>
+        <p:style>
+          <a:lnRef idx="1">
+            <a:schemeClr val="accent1"/>
+          </a:lnRef>
+          <a:fillRef idx="3">
+            <a:schemeClr val="accent1"/>
+          </a:fillRef>
+          <a:effectRef idx="2">
+            <a:schemeClr val="accent1"/>
+          </a:effectRef>
+          <a:fontRef idx="minor">
+            <a:schemeClr val="lt1"/>
+          </a:fontRef>
+        </p:style>
+        <p:txBody>
+          <a:bodyPr rtlCol="0" anchor="ctr"/>
+          <a:lstStyle/>
+          <a:p>
+            <a:pPr algn="ctr"/>
+          </a:p>
+        </p:txBody>
+      </p:sp>
+      <p:sp>
+        <p:nvSpPr>
+          <p:cNvPr id="76" name="TextBox 75"/>
+          <p:cNvSpPr txBox="1"/>
+          <p:nvPr/>
+        </p:nvSpPr>
+        <p:spPr>
+          <a:xfrm>
+            <a:off x="3462375" y="5399532"/>
+            <a:ext cx="1005840" cy="201168"/>
+          </a:xfrm>
+          <a:prstGeom prst="rect">
+            <a:avLst/>
+          </a:prstGeom>
+          <a:noFill/>
+        </p:spPr>
+        <p:txBody>
+          <a:bodyPr wrap="square" anchor="t" lIns="0" rIns="0" tIns="0" bIns="0">
+            <a:spAutoFit/>
+          </a:bodyPr>
+          <a:lstStyle/>
+          <a:p>
+            <a:pPr algn="l">
+              <a:lnSpc>
+                <a:spcPct val="100000"/>
+              </a:lnSpc>
+            </a:pPr>
+            <a:r>
+              <a:rPr sz="800" b="0">
+                <a:solidFill>
+                  <a:srgbClr val="8390A1"/>
                 </a:solidFill>
                 <a:latin typeface="Segoe UI"/>
               </a:rPr>
-              <a:t>engine 100% hit-rate, 8.3% avg. error on held-out parts (CI-gated) · 285 automated tests.   </a:t>
-            </a:r>
-            <a:r>
-              <a:rPr sz="1200" b="1">
-                <a:solidFill>
-                  <a:srgbClr val="B47609"/>
+              <a:t>43.7%  mass</a:t>
+            </a:r>
+          </a:p>
+        </p:txBody>
+      </p:sp>
+      <p:sp>
+        <p:nvSpPr>
+          <p:cNvPr id="77" name="Rounded Rectangle 76"/>
+          <p:cNvSpPr/>
+          <p:nvPr/>
+        </p:nvSpPr>
+        <p:spPr>
+          <a:xfrm>
+            <a:off x="1600200" y="5586984"/>
+            <a:ext cx="1419606" cy="105156"/>
+          </a:xfrm>
+          <a:prstGeom prst="roundRect">
+            <a:avLst/>
+          </a:prstGeom>
+          <a:solidFill>
+            <a:srgbClr val="0D9488"/>
+          </a:solidFill>
+          <a:ln>
+            <a:noFill/>
+          </a:ln>
+          <a:effectLst/>
+        </p:spPr>
+        <p:style>
+          <a:lnRef idx="1">
+            <a:schemeClr val="accent1"/>
+          </a:lnRef>
+          <a:fillRef idx="3">
+            <a:schemeClr val="accent1"/>
+          </a:fillRef>
+          <a:effectRef idx="2">
+            <a:schemeClr val="accent1"/>
+          </a:effectRef>
+          <a:fontRef idx="minor">
+            <a:schemeClr val="lt1"/>
+          </a:fontRef>
+        </p:style>
+        <p:txBody>
+          <a:bodyPr rtlCol="0" anchor="ctr"/>
+          <a:lstStyle/>
+          <a:p>
+            <a:pPr algn="ctr"/>
+          </a:p>
+        </p:txBody>
+      </p:sp>
+      <p:sp>
+        <p:nvSpPr>
+          <p:cNvPr id="78" name="TextBox 77"/>
+          <p:cNvSpPr txBox="1"/>
+          <p:nvPr/>
+        </p:nvSpPr>
+        <p:spPr>
+          <a:xfrm>
+            <a:off x="3083814" y="5545836"/>
+            <a:ext cx="1280160" cy="201168"/>
+          </a:xfrm>
+          <a:prstGeom prst="rect">
+            <a:avLst/>
+          </a:prstGeom>
+          <a:noFill/>
+        </p:spPr>
+        <p:txBody>
+          <a:bodyPr wrap="square" anchor="t" lIns="0" rIns="0" tIns="0" bIns="0">
+            <a:spAutoFit/>
+          </a:bodyPr>
+          <a:lstStyle/>
+          <a:p>
+            <a:pPr algn="l">
+              <a:lnSpc>
+                <a:spcPct val="100000"/>
+              </a:lnSpc>
+            </a:pPr>
+            <a:r>
+              <a:rPr sz="800" b="1">
+                <a:solidFill>
+                  <a:srgbClr val="0D9488"/>
                 </a:solidFill>
                 <a:latin typeface="Segoe UI Semibold"/>
               </a:rPr>
-              <a:t>Next:  </a:t>
-            </a:r>
-            <a:r>
-              <a:rPr sz="1150" b="0">
+              <a:t>34.5%  feature</a:t>
+            </a:r>
+          </a:p>
+        </p:txBody>
+      </p:sp>
+      <p:sp>
+        <p:nvSpPr>
+          <p:cNvPr id="79" name="TextBox 78"/>
+          <p:cNvSpPr txBox="1"/>
+          <p:nvPr/>
+        </p:nvSpPr>
+        <p:spPr>
+          <a:xfrm>
+            <a:off x="749808" y="5833872"/>
+            <a:ext cx="822960" cy="228600"/>
+          </a:xfrm>
+          <a:prstGeom prst="rect">
+            <a:avLst/>
+          </a:prstGeom>
+          <a:noFill/>
+        </p:spPr>
+        <p:txBody>
+          <a:bodyPr wrap="square" anchor="t" lIns="0" rIns="0" tIns="0" bIns="0">
+            <a:spAutoFit/>
+          </a:bodyPr>
+          <a:lstStyle/>
+          <a:p>
+            <a:pPr algn="l">
+              <a:lnSpc>
+                <a:spcPct val="100000"/>
+              </a:lnSpc>
+            </a:pPr>
+            <a:r>
+              <a:rPr sz="900" b="1">
                 <a:solidFill>
                   <a:srgbClr val="374558"/>
+                </a:solidFill>
+                <a:latin typeface="Segoe UI Semibold"/>
+              </a:rPr>
+              <a:t>Stamping</a:t>
+            </a:r>
+          </a:p>
+        </p:txBody>
+      </p:sp>
+      <p:sp>
+        <p:nvSpPr>
+          <p:cNvPr id="80" name="Rounded Rectangle 79"/>
+          <p:cNvSpPr/>
+          <p:nvPr/>
+        </p:nvSpPr>
+        <p:spPr>
+          <a:xfrm>
+            <a:off x="1600200" y="5824728"/>
+            <a:ext cx="3077870" cy="105156"/>
+          </a:xfrm>
+          <a:prstGeom prst="roundRect">
+            <a:avLst/>
+          </a:prstGeom>
+          <a:solidFill>
+            <a:srgbClr val="8390A1"/>
+          </a:solidFill>
+          <a:ln>
+            <a:noFill/>
+          </a:ln>
+          <a:effectLst/>
+        </p:spPr>
+        <p:style>
+          <a:lnRef idx="1">
+            <a:schemeClr val="accent1"/>
+          </a:lnRef>
+          <a:fillRef idx="3">
+            <a:schemeClr val="accent1"/>
+          </a:fillRef>
+          <a:effectRef idx="2">
+            <a:schemeClr val="accent1"/>
+          </a:effectRef>
+          <a:fontRef idx="minor">
+            <a:schemeClr val="lt1"/>
+          </a:fontRef>
+        </p:style>
+        <p:txBody>
+          <a:bodyPr rtlCol="0" anchor="ctr"/>
+          <a:lstStyle/>
+          <a:p>
+            <a:pPr algn="ctr"/>
+          </a:p>
+        </p:txBody>
+      </p:sp>
+      <p:sp>
+        <p:nvSpPr>
+          <p:cNvPr id="81" name="TextBox 80"/>
+          <p:cNvSpPr txBox="1"/>
+          <p:nvPr/>
+        </p:nvSpPr>
+        <p:spPr>
+          <a:xfrm>
+            <a:off x="4742078" y="5783580"/>
+            <a:ext cx="1005840" cy="201168"/>
+          </a:xfrm>
+          <a:prstGeom prst="rect">
+            <a:avLst/>
+          </a:prstGeom>
+          <a:noFill/>
+        </p:spPr>
+        <p:txBody>
+          <a:bodyPr wrap="square" anchor="t" lIns="0" rIns="0" tIns="0" bIns="0">
+            <a:spAutoFit/>
+          </a:bodyPr>
+          <a:lstStyle/>
+          <a:p>
+            <a:pPr algn="l">
+              <a:lnSpc>
+                <a:spcPct val="100000"/>
+              </a:lnSpc>
+            </a:pPr>
+            <a:r>
+              <a:rPr sz="800" b="0">
+                <a:solidFill>
+                  <a:srgbClr val="8390A1"/>
                 </a:solidFill>
                 <a:latin typeface="Segoe UI"/>
               </a:rPr>
-              <a:t>5-minute live demo, then a pilot on one active programme.</a:t>
+              <a:t>74.8%  mass</a:t>
+            </a:r>
+          </a:p>
+        </p:txBody>
+      </p:sp>
+      <p:sp>
+        <p:nvSpPr>
+          <p:cNvPr id="82" name="Rounded Rectangle 81"/>
+          <p:cNvSpPr/>
+          <p:nvPr/>
+        </p:nvSpPr>
+        <p:spPr>
+          <a:xfrm>
+            <a:off x="1600200" y="5971032"/>
+            <a:ext cx="1600657" cy="105156"/>
+          </a:xfrm>
+          <a:prstGeom prst="roundRect">
+            <a:avLst/>
+          </a:prstGeom>
+          <a:solidFill>
+            <a:srgbClr val="0D9488"/>
+          </a:solidFill>
+          <a:ln>
+            <a:noFill/>
+          </a:ln>
+          <a:effectLst/>
+        </p:spPr>
+        <p:style>
+          <a:lnRef idx="1">
+            <a:schemeClr val="accent1"/>
+          </a:lnRef>
+          <a:fillRef idx="3">
+            <a:schemeClr val="accent1"/>
+          </a:fillRef>
+          <a:effectRef idx="2">
+            <a:schemeClr val="accent1"/>
+          </a:effectRef>
+          <a:fontRef idx="minor">
+            <a:schemeClr val="lt1"/>
+          </a:fontRef>
+        </p:style>
+        <p:txBody>
+          <a:bodyPr rtlCol="0" anchor="ctr"/>
+          <a:lstStyle/>
+          <a:p>
+            <a:pPr algn="ctr"/>
+          </a:p>
+        </p:txBody>
+      </p:sp>
+      <p:sp>
+        <p:nvSpPr>
+          <p:cNvPr id="83" name="TextBox 82"/>
+          <p:cNvSpPr txBox="1"/>
+          <p:nvPr/>
+        </p:nvSpPr>
+        <p:spPr>
+          <a:xfrm>
+            <a:off x="3264865" y="5929884"/>
+            <a:ext cx="1280160" cy="201168"/>
+          </a:xfrm>
+          <a:prstGeom prst="rect">
+            <a:avLst/>
+          </a:prstGeom>
+          <a:noFill/>
+        </p:spPr>
+        <p:txBody>
+          <a:bodyPr wrap="square" anchor="t" lIns="0" rIns="0" tIns="0" bIns="0">
+            <a:spAutoFit/>
+          </a:bodyPr>
+          <a:lstStyle/>
+          <a:p>
+            <a:pPr algn="l">
+              <a:lnSpc>
+                <a:spcPct val="100000"/>
+              </a:lnSpc>
+            </a:pPr>
+            <a:r>
+              <a:rPr sz="800" b="1">
+                <a:solidFill>
+                  <a:srgbClr val="0D9488"/>
+                </a:solidFill>
+                <a:latin typeface="Segoe UI Semibold"/>
+              </a:rPr>
+              <a:t>38.9%  feature</a:t>
+            </a:r>
+          </a:p>
+        </p:txBody>
+      </p:sp>
+      <p:sp>
+        <p:nvSpPr>
+          <p:cNvPr id="84" name="Rounded Rectangle 83"/>
+          <p:cNvSpPr/>
+          <p:nvPr/>
+        </p:nvSpPr>
+        <p:spPr>
+          <a:xfrm>
+            <a:off x="6400800" y="4983480"/>
+            <a:ext cx="5239512" cy="1188720"/>
+          </a:xfrm>
+          <a:prstGeom prst="roundRect">
+            <a:avLst/>
+          </a:prstGeom>
+          <a:solidFill>
+            <a:srgbClr val="FFFFFF"/>
+          </a:solidFill>
+          <a:ln w="12700">
+            <a:solidFill>
+              <a:srgbClr val="D8E0EA"/>
+            </a:solidFill>
+          </a:ln>
+          <a:effectLst/>
+        </p:spPr>
+        <p:style>
+          <a:lnRef idx="1">
+            <a:schemeClr val="accent1"/>
+          </a:lnRef>
+          <a:fillRef idx="3">
+            <a:schemeClr val="accent1"/>
+          </a:fillRef>
+          <a:effectRef idx="2">
+            <a:schemeClr val="accent1"/>
+          </a:effectRef>
+          <a:fontRef idx="minor">
+            <a:schemeClr val="lt1"/>
+          </a:fontRef>
+        </p:style>
+        <p:txBody>
+          <a:bodyPr rtlCol="0" anchor="ctr"/>
+          <a:lstStyle/>
+          <a:p>
+            <a:pPr algn="ctr"/>
+          </a:p>
+        </p:txBody>
+      </p:sp>
+      <p:sp>
+        <p:nvSpPr>
+          <p:cNvPr id="85" name="Rounded Rectangle 84"/>
+          <p:cNvSpPr/>
+          <p:nvPr/>
+        </p:nvSpPr>
+        <p:spPr>
+          <a:xfrm>
+            <a:off x="6601968" y="5102352"/>
+            <a:ext cx="274320" cy="274320"/>
+          </a:xfrm>
+          <a:prstGeom prst="roundRect">
+            <a:avLst/>
+          </a:prstGeom>
+          <a:solidFill>
+            <a:srgbClr val="059669"/>
+          </a:solidFill>
+          <a:ln>
+            <a:noFill/>
+          </a:ln>
+          <a:effectLst/>
+        </p:spPr>
+        <p:style>
+          <a:lnRef idx="1">
+            <a:schemeClr val="accent1"/>
+          </a:lnRef>
+          <a:fillRef idx="3">
+            <a:schemeClr val="accent1"/>
+          </a:fillRef>
+          <a:effectRef idx="2">
+            <a:schemeClr val="accent1"/>
+          </a:effectRef>
+          <a:fontRef idx="minor">
+            <a:schemeClr val="lt1"/>
+          </a:fontRef>
+        </p:style>
+        <p:txBody>
+          <a:bodyPr rtlCol="0" anchor="ctr"/>
+          <a:lstStyle/>
+          <a:p>
+            <a:pPr algn="ctr"/>
+          </a:p>
+        </p:txBody>
+      </p:sp>
+      <p:pic>
+        <p:nvPicPr>
+          <p:cNvPr id="86" name="Picture 85" descr="shield.png"/>
+          <p:cNvPicPr>
+            <a:picLocks noChangeAspect="1"/>
+          </p:cNvPicPr>
+          <p:nvPr/>
+        </p:nvPicPr>
+        <p:blipFill>
+          <a:blip r:embed="rId15"/>
+          <a:stretch>
+            <a:fillRect/>
+          </a:stretch>
+        </p:blipFill>
+        <p:spPr>
+          <a:xfrm>
+            <a:off x="6651345" y="5151729"/>
+            <a:ext cx="175566" cy="175566"/>
+          </a:xfrm>
+          <a:prstGeom prst="rect">
+            <a:avLst/>
+          </a:prstGeom>
+        </p:spPr>
+      </p:pic>
+      <p:sp>
+        <p:nvSpPr>
+          <p:cNvPr id="87" name="TextBox 86"/>
+          <p:cNvSpPr txBox="1"/>
+          <p:nvPr/>
+        </p:nvSpPr>
+        <p:spPr>
+          <a:xfrm>
+            <a:off x="6986016" y="5120640"/>
+            <a:ext cx="4480560" cy="274320"/>
+          </a:xfrm>
+          <a:prstGeom prst="rect">
+            <a:avLst/>
+          </a:prstGeom>
+          <a:noFill/>
+        </p:spPr>
+        <p:txBody>
+          <a:bodyPr wrap="square" anchor="t" lIns="0" rIns="0" tIns="0" bIns="0">
+            <a:spAutoFit/>
+          </a:bodyPr>
+          <a:lstStyle/>
+          <a:p>
+            <a:pPr algn="l">
+              <a:lnSpc>
+                <a:spcPct val="100000"/>
+              </a:lnSpc>
+            </a:pPr>
+            <a:r>
+              <a:rPr sz="850" b="1">
+                <a:solidFill>
+                  <a:srgbClr val="8390A1"/>
+                </a:solidFill>
+                <a:latin typeface="Segoe UI Semibold"/>
+              </a:rPr>
+              <a:t>PROOF, NOT PROMISES</a:t>
+            </a:r>
+          </a:p>
+        </p:txBody>
+      </p:sp>
+      <p:sp>
+        <p:nvSpPr>
+          <p:cNvPr id="88" name="TextBox 87"/>
+          <p:cNvSpPr txBox="1"/>
+          <p:nvPr/>
+        </p:nvSpPr>
+        <p:spPr>
+          <a:xfrm>
+            <a:off x="6601968" y="5440680"/>
+            <a:ext cx="4846320" cy="320040"/>
+          </a:xfrm>
+          <a:prstGeom prst="rect">
+            <a:avLst/>
+          </a:prstGeom>
+          <a:noFill/>
+        </p:spPr>
+        <p:txBody>
+          <a:bodyPr wrap="square" anchor="t" lIns="0" rIns="0" tIns="0" bIns="0">
+            <a:spAutoFit/>
+          </a:bodyPr>
+          <a:lstStyle/>
+          <a:p>
+            <a:pPr algn="l">
+              <a:lnSpc>
+                <a:spcPct val="100000"/>
+              </a:lnSpc>
+            </a:pPr>
+            <a:r>
+              <a:rPr sz="1050" b="0">
+                <a:solidFill>
+                  <a:srgbClr val="374558"/>
+                </a:solidFill>
+                <a:latin typeface="Segoe UI"/>
+              </a:rPr>
+              <a:t>Core engine: </a:t>
+            </a:r>
+            <a:r>
+              <a:rPr sz="1050" b="1">
+                <a:solidFill>
+                  <a:srgbClr val="16273C"/>
+                </a:solidFill>
+                <a:latin typeface="Segoe UI Semibold"/>
+              </a:rPr>
+              <a:t>100% hit-rate · 8.3% avg. error</a:t>
+            </a:r>
+            <a:r>
+              <a:rPr sz="1050" b="0">
+                <a:solidFill>
+                  <a:srgbClr val="374558"/>
+                </a:solidFill>
+                <a:latin typeface="Segoe UI"/>
+              </a:rPr>
+              <a:t> (CI-gated) · 285 tests</a:t>
+            </a:r>
+          </a:p>
+        </p:txBody>
+      </p:sp>
+      <p:sp>
+        <p:nvSpPr>
+          <p:cNvPr id="89" name="Rounded Rectangle 88"/>
+          <p:cNvSpPr/>
+          <p:nvPr/>
+        </p:nvSpPr>
+        <p:spPr>
+          <a:xfrm>
+            <a:off x="6601968" y="5779008"/>
+            <a:ext cx="274320" cy="274320"/>
+          </a:xfrm>
+          <a:prstGeom prst="roundRect">
+            <a:avLst/>
+          </a:prstGeom>
+          <a:solidFill>
+            <a:srgbClr val="B47609"/>
+          </a:solidFill>
+          <a:ln>
+            <a:noFill/>
+          </a:ln>
+          <a:effectLst/>
+        </p:spPr>
+        <p:style>
+          <a:lnRef idx="1">
+            <a:schemeClr val="accent1"/>
+          </a:lnRef>
+          <a:fillRef idx="3">
+            <a:schemeClr val="accent1"/>
+          </a:fillRef>
+          <a:effectRef idx="2">
+            <a:schemeClr val="accent1"/>
+          </a:effectRef>
+          <a:fontRef idx="minor">
+            <a:schemeClr val="lt1"/>
+          </a:fontRef>
+        </p:style>
+        <p:txBody>
+          <a:bodyPr rtlCol="0" anchor="ctr"/>
+          <a:lstStyle/>
+          <a:p>
+            <a:pPr algn="ctr"/>
+          </a:p>
+        </p:txBody>
+      </p:sp>
+      <p:pic>
+        <p:nvPicPr>
+          <p:cNvPr id="90" name="Picture 89" descr="play.png"/>
+          <p:cNvPicPr>
+            <a:picLocks noChangeAspect="1"/>
+          </p:cNvPicPr>
+          <p:nvPr/>
+        </p:nvPicPr>
+        <p:blipFill>
+          <a:blip r:embed="rId16"/>
+          <a:stretch>
+            <a:fillRect/>
+          </a:stretch>
+        </p:blipFill>
+        <p:spPr>
+          <a:xfrm>
+            <a:off x="6651345" y="5828385"/>
+            <a:ext cx="175566" cy="175566"/>
+          </a:xfrm>
+          <a:prstGeom prst="rect">
+            <a:avLst/>
+          </a:prstGeom>
+        </p:spPr>
+      </p:pic>
+      <p:sp>
+        <p:nvSpPr>
+          <p:cNvPr id="91" name="TextBox 90"/>
+          <p:cNvSpPr txBox="1"/>
+          <p:nvPr/>
+        </p:nvSpPr>
+        <p:spPr>
+          <a:xfrm>
+            <a:off x="6986016" y="5815584"/>
+            <a:ext cx="4572000" cy="292608"/>
+          </a:xfrm>
+          <a:prstGeom prst="rect">
+            <a:avLst/>
+          </a:prstGeom>
+          <a:noFill/>
+        </p:spPr>
+        <p:txBody>
+          <a:bodyPr wrap="square" anchor="t" lIns="0" rIns="0" tIns="0" bIns="0">
+            <a:spAutoFit/>
+          </a:bodyPr>
+          <a:lstStyle/>
+          <a:p>
+            <a:pPr algn="l">
+              <a:lnSpc>
+                <a:spcPct val="100000"/>
+              </a:lnSpc>
+            </a:pPr>
+            <a:r>
+              <a:rPr sz="1050" b="1">
+                <a:solidFill>
+                  <a:srgbClr val="B47609"/>
+                </a:solidFill>
+                <a:latin typeface="Segoe UI Semibold"/>
+              </a:rPr>
+              <a:t>Next: </a:t>
+            </a:r>
+            <a:r>
+              <a:rPr sz="1050" b="0">
+                <a:solidFill>
+                  <a:srgbClr val="374558"/>
+                </a:solidFill>
+                <a:latin typeface="Segoe UI"/>
+              </a:rPr>
+              <a:t>5-minute live demo, then a pilot on one programme.</a:t>
             </a:r>
           </a:p>
         </p:txBody>

</xml_diff>